<commit_message>
docs(slides): apply Aaron's review fixes to the Week 11 deck
Applies the points from Aaron's 30 Oct review of eb65d5e on Bryan's behalf:
- slide 2: ceremony links become placeholders until the team adds them;
- slide 4: cite #371 for status polymorphism, not T-59/T-63;
- slide 6: example 1 states only what the repo records (T-59, rollback
  isolation, isSafeResetTarget); example 2 says 739 run records;
  example 3 cites T-100 and the FOR UPDATE locks, not T-63/T-68;
- slide 9: feature/ branch prefix;
- slide 10: no open issues as of 30 Oct;
- slide 12: no linter; check.py and the tc-coverage audit run in
  repository-checks;
- slide 14: CI example rewritten around #355's schema drift (run
  40331728045, fixed in 2e7b580);
- slide 15: Amareet's text columns as requested, with lower minimum row
  heights so the table stays on the slide.

Co-Authored-By: Claude Opus 5.5 <noreply@anthropic.com>
</commit_message>
<xml_diff>
--- a/docs/slides/presentation/Week 11 Presentation.pptx
+++ b/docs/slides/presentation/Week 11 Presentation.pptx
@@ -4663,7 +4663,7 @@
                         <a:defRPr sz="1000"/>
                       </a:pPr>
                       <a:r>
-                        <a:t>Open follow-ups: PRs #309, #328, #361; 1 open issue; no Done story reopened</a:t>
+                        <a:t>Open follow-ups: PRs #309, #328, #361; no open issues (30 Oct 2026); no Done story reopened</a:t>
                       </a:r>
                     </a:p>
                   </a:txBody>
@@ -5452,7 +5452,7 @@
                         <a:defRPr sz="1000"/>
                       </a:pPr>
                       <a:r>
-                        <a:t>pr-conventions, pr-guardrails (max 2 PRs/author), application-checks (lint, typecheck, Vitest, backend unit/db, Playwright E2E, check.py, tc-coverage audit).</a:t>
+                        <a:t>repository-checks (check.py, tc-coverage audit), pr-conventions, pr-guardrails (max 2 PRs/author), application-checks (typecheck, Vitest, backend unit/db, Playwright E2E).</a:t>
                       </a:r>
                     </a:p>
                   </a:txBody>
@@ -6102,7 +6102,7 @@
               <a:defRPr sz="1200"/>
             </a:pPr>
             <a:r>
-              <a:t>PR #373: Fix flaky focus assertion on RefusedEdit.navigation.test.tsx (E10-S01 / Issue #372).</a:t>
+              <a:t>PR #355 (Ji Ning): lost venue replacement recovery (E10), commit b0f0dc6, 26 Oct 2026.</a:t>
             </a:r>
           </a:p>
         </p:txBody>
@@ -6191,7 +6191,7 @@
               <a:defRPr sz="1200"/>
             </a:pPr>
             <a:r>
-              <a:t>pr-guardrails check failed with error: 'Author bryanseah234 has 3 open PRs (limit is 2: #370, #371, #373)'.</a:t>
+              <a:t>application-checks, step "E06-S03 booking submission and status PostgreSQL acceptance": TC_E06S03_05 failed because column b.conflict_block_id did not exist (GitHub Actions run 40331728045).</a:t>
             </a:r>
           </a:p>
         </p:txBody>
@@ -6280,7 +6280,7 @@
               <a:defRPr sz="1200"/>
             </a:pPr>
             <a:r>
-              <a:t>The automated guardrail prevented WIP overload and author bottlenecking. It ensured that developer attention was focused on reviewing and merging pending in-flight PRs (#370, #371) before introducing additional work into the pipeline.</a:t>
+              <a:t>The booking request-list query reads conflict_block_id, added by migration 0025 (venue unavailability, #348), but that suite's fixture built its PostgreSQL schema from only migrations 0001 and 0019. The code and the schema it was tested against had drifted apart, and the real-PostgreSQL CI step caught it before merge.</a:t>
             </a:r>
           </a:p>
         </p:txBody>
@@ -6369,7 +6369,7 @@
               <a:defRPr sz="1200"/>
             </a:pPr>
             <a:r>
-              <a:t>Reconciled and reviewed upstream dependencies, merged PR #368 and ready review items, unblocking the author's queue so PR #373 could cleanly merge with green CI across all 16 checks.</a:t>
+              <a:t>Commit 2e7b580 made the fixture apply all current migrations while keeping its pre-migration rows and the 0019 backfill assertion. CI passed and #355 merged on 27 Oct 2026. Record: docs/testing/runs/20261026-215233-jininggg-backend-api.md.</a:t>
             </a:r>
           </a:p>
         </p:txBody>
@@ -6576,7 +6576,7 @@
                   </a:extLst>
                 </a:gridCol>
               </a:tblGrid>
-              <a:tr h="760000">
+              <a:tr h="560000">
                 <a:tc>
                   <a:txBody>
                     <a:bodyPr/>
@@ -6668,7 +6668,7 @@
                   </a:ext>
                 </a:extLst>
               </a:tr>
-              <a:tr h="630000">
+              <a:tr h="480000">
                 <a:tc>
                   <a:txBody>
                     <a:bodyPr/>
@@ -6750,7 +6750,7 @@
                   <a:tcPr anchor="ctr"/>
                 </a:tc>
               </a:tr>
-              <a:tr h="630000">
+              <a:tr h="480000">
                 <a:tc>
                   <a:txBody>
                     <a:bodyPr/>
@@ -6832,7 +6832,7 @@
                   <a:tcPr anchor="ctr"/>
                 </a:tc>
               </a:tr>
-              <a:tr h="630000">
+              <a:tr h="480000">
                 <a:tc>
                   <a:txBody>
                     <a:bodyPr/>
@@ -6914,7 +6914,7 @@
                   <a:tcPr anchor="ctr"/>
                 </a:tc>
               </a:tr>
-              <a:tr h="630000">
+              <a:tr h="480000">
                 <a:tc>
                   <a:txBody>
                     <a:bodyPr/>
@@ -6996,7 +6996,7 @@
                   <a:tcPr anchor="ctr"/>
                 </a:tc>
               </a:tr>
-              <a:tr h="630000">
+              <a:tr h="480000">
                 <a:tc>
                   <a:txBody>
                     <a:bodyPr/>
@@ -7078,7 +7078,7 @@
                   <a:tcPr anchor="ctr"/>
                 </a:tc>
               </a:tr>
-              <a:tr h="630000">
+              <a:tr h="480000">
                 <a:tc>
                   <a:txBody>
                     <a:bodyPr/>
@@ -7105,7 +7105,7 @@
                       </a:pPr>
                       <a:r>
                         <a:rPr lang="en-SG"/>
-                        <a:t>Frontend platform (routing, shell, templates), technical support, tentative holds, registration and capacity</a:t>
+                        <a:t>Frontend skeleton and shared shell (route table, page templates, shared building blocks, design tokens); technical support requests and technician staffing (E07-S06, E07-S07); tentative venue holds (E06-S05); attendee registration, capacity, registration period and registration list (E09-S01, S02, S03, S07), including migrations 0023–0024</a:t>
                       </a:r>
                     </a:p>
                   </a:txBody>
@@ -7153,7 +7153,7 @@
                       </a:pPr>
                       <a:r>
                         <a:rPr lang="en-SG"/>
-                        <a:t>E09 manual run records and screenshots</a:t>
+                        <a:t>Scrum Master: daily standups and sprint ceremonies, Jira board upkeep; reviewed 100+ teammates' merged PRs; aligned the Definition of Done with the Week 7 guidance (#215); re-estimation PRs (#213, #323); E06-S05, E07-S06/S07 and E09 manual run records with screenshots</a:t>
                       </a:r>
                     </a:p>
                   </a:txBody>
@@ -7876,7 +7876,7 @@
                         <a:defRPr sz="1100"/>
                       </a:pPr>
                       <a:r>
-                        <a:t>Sprint 4 Ceremonies: Standup, Review, Retrospective - recording links to be inserted before submission (not yet in the repo)</a:t>
+                        <a:t>Sprint 4 Ceremonies: Standup [link to be added], Review [link to be added], Retrospective [link to be added]</a:t>
                       </a:r>
                     </a:p>
                   </a:txBody>
@@ -8444,7 +8444,7 @@
           </a:p>
           <a:p>
             <a:r>
-              <a:t>Introducing post-confirmation cancellation rules and attendee waiting lists changed the transactional state machine. When a place is released, every waitlisted Attendee is notified and the place goes to whoever claims first (C-23, T-33, T-46): there is no ordered queue, no automatic promotion and no hold window. Cancelling an Event also notifies affected Attendees, closes obsolete change requests and releases Session arrangements in one transaction with audit records. This required atomic transactions, status polymorphism (T-59/T-63) and regression tests.</a:t>
+              <a:t>Introducing post-confirmation cancellation rules and attendee waiting lists changed the transactional state machine. When a place is released, every waitlisted Attendee is notified and the place goes to whoever claims first (C-23, T-33, T-46): there is no ordered queue, no automatic promotion and no hold window. Cancelling an Event also notifies affected Attendees, closes obsolete change requests and releases Session arrangements in one transaction with audit records. This required atomic transactions, status polymorphism (#371) and regression tests.</a:t>
             </a:r>
           </a:p>
         </p:txBody>
@@ -9149,7 +9149,7 @@
                         <a:defRPr sz="1000"/>
                       </a:pPr>
                       <a:r>
-                        <a:t>Generated naive db:reset scripts that wiped shared Supabase DB schemas during teardown.</a:t>
+                        <a:t>Could generate a db:reset that drops the schema of whatever DATABASE_URL points at, including the shared Supabase database.</a:t>
                       </a:r>
                     </a:p>
                   </a:txBody>
@@ -9164,7 +9164,7 @@
                         <a:defRPr sz="1000"/>
                       </a:pPr>
                       <a:r>
-                        <a:t>Architected T-59: an isolated Supabase test schema using rollback-based transactional saves guarded by CI gates.</a:t>
+                        <a:t>T-59: a separate test schema in the same Supabase project, transaction-rollback isolation for database tests, and isSafeResetTarget(), which refuses db:reset unless the host is local or the database name contains test or dev (or ALLOW_DATABASE_RESET is set on purpose).</a:t>
                       </a:r>
                     </a:p>
                   </a:txBody>
@@ -9179,7 +9179,7 @@
                         <a:defRPr sz="1000"/>
                       </a:pPr>
                       <a:r>
-                        <a:t>Prevented catastrophic wiping of shared staging/test data and protected cloud credentials.</a:t>
+                        <a:t>Database tests and resets cannot wipe the shared Supabase data, and there is no second database URL to rotate.</a:t>
                       </a:r>
                     </a:p>
                   </a:txBody>
@@ -9194,7 +9194,7 @@
                         <a:defRPr sz="1000"/>
                       </a:pPr>
                       <a:r>
-                        <a:t>docs/bdr/B-team-decisions.md (T-59), scripts/check.py, docs/testing/supabase-test-schema.md</a:t>
+                        <a:t>docs/bdr/B-team-decisions.md (T-59), docs/testing/supabase-test-schema.md, backend/src/database/cli.ts (isSafeResetTarget)</a:t>
                       </a:r>
                     </a:p>
                   </a:txBody>
@@ -9276,7 +9276,7 @@
                         <a:defRPr sz="1000"/>
                       </a:pPr>
                       <a:r>
-                        <a:t>737 run records in docs/testing/runs/, evidence/ directories with PNGs (e.g. PR #368, PR #373)</a:t>
+                        <a:t>739 run records in docs/testing/runs/, evidence/ directories with PNGs (e.g. PR #368, PR #373)</a:t>
                       </a:r>
                     </a:p>
                   </a:txBody>
@@ -9328,7 +9328,7 @@
                         <a:defRPr sz="1000"/>
                       </a:pPr>
                       <a:r>
-                        <a:t>Designed Booking Status Polymorphism and Rule B First Accepted Claim logic with PostgreSQL row-level locks.</a:t>
+                        <a:t>Designed Booking Status Polymorphism (#371) and the T-100 rule B first accepted claim, serialised with PostgreSQL row-level locks (FOR UPDATE).</a:t>
                       </a:r>
                     </a:p>
                   </a:txBody>
@@ -9358,7 +9358,7 @@
                         <a:defRPr sz="1000"/>
                       </a:pPr>
                       <a:r>
-                        <a:t>PR #339, PR #371, docs/bdr/B-team-decisions.md (T-63/T-68), backend/src/modules/venueBooking/</a:t>
+                        <a:t>PR #339, PR #371, docs/bdr/B-team-decisions.md (T-100), FOR UPDATE locks in backend/src/modules/venueBooking/</a:t>
                       </a:r>
                     </a:p>
                   </a:txBody>
@@ -10371,7 +10371,7 @@
               <a:defRPr sz="1300"/>
             </a:pPr>
             <a:r>
-              <a:t>• Trunk-Based Collaboration with Short-Lived Branches: Enforced strict branch prefixes (feat/, fix/, docs/, test/, chore/) tied directly to Jira keys (e.g. feature/SCRUM-216-e09-registration-list).</a:t>
+              <a:t>• Trunk-Based Collaboration with Short-Lived Branches: Enforced strict branch prefixes (feature/, fix/, docs/, test/, chore/) tied directly to Jira keys (e.g. feature/SCRUM-216-e09-registration-list).</a:t>
             </a:r>
           </a:p>
           <a:p>

</xml_diff>

<commit_message>
docs(slides): fix Week 11 deck layout and claims outside the review
Second pass on the deck, for the slides and rows no review had checked:
- answer boxes on slides 4, 5, 7, 9, 10, 11, 13 and 16 now use one font
  size each and are stacked so no text overlaps or runs off the slide;
- claims the repository does not support are reworded to what it
  records: slide 5's files and tests, slide 6's examples 2 and 3, slide
  7's rework examples and decisions, slide 8's CI list, slide 9's
  worktree and merge history, slide 10's check-run count, slide 11's
  edge cases and CFO sentence, slide 12's triggers, required checks,
  CI-caught example and bypass answer, slide 13's overclaims, slide 15's
  "near-match scoring" and slide 16's Sprint 4 points.

Co-Authored-By: Claude Opus 5.5 <noreply@anthropic.com>
</commit_message>
<xml_diff>
--- a/docs/slides/presentation/Week 11 Presentation.pptx
+++ b/docs/slides/presentation/Week 11 Presentation.pptx
@@ -123,6 +123,11 @@
       </a:defRPr>
     </a:lvl9pPr>
   </p:defaultTextStyle>
+  <p:extLst>
+    <p:ext uri="{EFAFB233-063F-42B5-8137-9DF3F51BA10A}">
+      <p15:sldGuideLst xmlns:p15="http://schemas.microsoft.com/office/powerpoint/2012/main"/>
+    </p:ext>
+  </p:extLst>
 </p:presentation>
 </file>
 
@@ -145,345 +150,6 @@
 
 <file path=ppt/changesInfos/changesInfo1.xml><?xml version="1.0" encoding="utf-8"?>
 <pc:chgInfo xmlns:a="http://schemas.openxmlformats.org/drawingml/2006/main" xmlns:r="http://schemas.openxmlformats.org/officeDocument/2006/relationships" xmlns:ac="http://schemas.microsoft.com/office/drawing/2013/main/command" xmlns:pc="http://schemas.microsoft.com/office/powerpoint/2013/main/command">
-  <pc:docChgLst>
-    <pc:chgData name="Christopher Michael POSKITT" userId="4bd18c9c-05ca-44c7-aeca-cc78c750a47e" providerId="ADAL" clId="{7B141A95-E539-59F1-A1E4-CD0859CEB3EE}"/>
-    <pc:docChg chg="undo custSel addSld modSld">
-      <pc:chgData name="Christopher Michael POSKITT" userId="4bd18c9c-05ca-44c7-aeca-cc78c750a47e" providerId="ADAL" clId="{7B141A95-E539-59F1-A1E4-CD0859CEB3EE}" dt="2026-10-26T09:00:08.084" v="1509" actId="20577"/>
-      <pc:docMkLst>
-        <pc:docMk/>
-      </pc:docMkLst>
-      <pc:sldChg chg="modSp mod">
-        <pc:chgData name="Christopher Michael POSKITT" userId="4bd18c9c-05ca-44c7-aeca-cc78c750a47e" providerId="ADAL" clId="{7B141A95-E539-59F1-A1E4-CD0859CEB3EE}" dt="2026-10-26T08:35:42.890" v="399" actId="20577"/>
-        <pc:sldMkLst>
-          <pc:docMk/>
-          <pc:sldMk cId="62309270" sldId="258"/>
-        </pc:sldMkLst>
-        <pc:spChg chg="mod">
-          <ac:chgData name="Christopher Michael POSKITT" userId="4bd18c9c-05ca-44c7-aeca-cc78c750a47e" providerId="ADAL" clId="{7B141A95-E539-59F1-A1E4-CD0859CEB3EE}" dt="2026-10-26T08:35:42.890" v="399" actId="20577"/>
-          <ac:spMkLst>
-            <pc:docMk/>
-            <pc:sldMk cId="62309270" sldId="258"/>
-            <ac:spMk id="3" creationId="{E7DA8B45-FD63-2AF7-E6C3-CA68DA63B13A}"/>
-          </ac:spMkLst>
-        </pc:spChg>
-      </pc:sldChg>
-      <pc:sldChg chg="modSp mod">
-        <pc:chgData name="Christopher Michael POSKITT" userId="4bd18c9c-05ca-44c7-aeca-cc78c750a47e" providerId="ADAL" clId="{7B141A95-E539-59F1-A1E4-CD0859CEB3EE}" dt="2026-10-26T08:34:25.709" v="265" actId="20577"/>
-        <pc:sldMkLst>
-          <pc:docMk/>
-          <pc:sldMk cId="1394506334" sldId="266"/>
-        </pc:sldMkLst>
-        <pc:spChg chg="mod">
-          <ac:chgData name="Christopher Michael POSKITT" userId="4bd18c9c-05ca-44c7-aeca-cc78c750a47e" providerId="ADAL" clId="{7B141A95-E539-59F1-A1E4-CD0859CEB3EE}" dt="2026-10-26T08:34:25.709" v="265" actId="20577"/>
-          <ac:spMkLst>
-            <pc:docMk/>
-            <pc:sldMk cId="1394506334" sldId="266"/>
-            <ac:spMk id="3" creationId="{559B88C5-EAD0-C571-42F7-8A17AE7DAE54}"/>
-          </ac:spMkLst>
-        </pc:spChg>
-        <pc:spChg chg="mod">
-          <ac:chgData name="Christopher Michael POSKITT" userId="4bd18c9c-05ca-44c7-aeca-cc78c750a47e" providerId="ADAL" clId="{7B141A95-E539-59F1-A1E4-CD0859CEB3EE}" dt="2026-10-26T08:33:52.082" v="263" actId="20577"/>
-          <ac:spMkLst>
-            <pc:docMk/>
-            <pc:sldMk cId="1394506334" sldId="266"/>
-            <ac:spMk id="10" creationId="{F394F906-2072-545D-27BE-D172B0E4394F}"/>
-          </ac:spMkLst>
-        </pc:spChg>
-      </pc:sldChg>
-      <pc:sldChg chg="modSp mod">
-        <pc:chgData name="Christopher Michael POSKITT" userId="4bd18c9c-05ca-44c7-aeca-cc78c750a47e" providerId="ADAL" clId="{7B141A95-E539-59F1-A1E4-CD0859CEB3EE}" dt="2026-10-26T08:35:03.639" v="273" actId="20577"/>
-        <pc:sldMkLst>
-          <pc:docMk/>
-          <pc:sldMk cId="1949106433" sldId="267"/>
-        </pc:sldMkLst>
-        <pc:spChg chg="mod">
-          <ac:chgData name="Christopher Michael POSKITT" userId="4bd18c9c-05ca-44c7-aeca-cc78c750a47e" providerId="ADAL" clId="{7B141A95-E539-59F1-A1E4-CD0859CEB3EE}" dt="2026-10-26T08:35:03.639" v="273" actId="20577"/>
-          <ac:spMkLst>
-            <pc:docMk/>
-            <pc:sldMk cId="1949106433" sldId="267"/>
-            <ac:spMk id="10" creationId="{723157CC-C155-A981-CD6B-F603456109E5}"/>
-          </ac:spMkLst>
-        </pc:spChg>
-      </pc:sldChg>
-      <pc:sldChg chg="modSp mod">
-        <pc:chgData name="Christopher Michael POSKITT" userId="4bd18c9c-05ca-44c7-aeca-cc78c750a47e" providerId="ADAL" clId="{7B141A95-E539-59F1-A1E4-CD0859CEB3EE}" dt="2026-10-26T08:37:51.719" v="411" actId="20577"/>
-        <pc:sldMkLst>
-          <pc:docMk/>
-          <pc:sldMk cId="2708235050" sldId="269"/>
-        </pc:sldMkLst>
-        <pc:spChg chg="mod">
-          <ac:chgData name="Christopher Michael POSKITT" userId="4bd18c9c-05ca-44c7-aeca-cc78c750a47e" providerId="ADAL" clId="{7B141A95-E539-59F1-A1E4-CD0859CEB3EE}" dt="2026-10-26T08:37:51.719" v="411" actId="20577"/>
-          <ac:spMkLst>
-            <pc:docMk/>
-            <pc:sldMk cId="2708235050" sldId="269"/>
-            <ac:spMk id="12" creationId="{EC0C83F2-486B-943F-791A-A1D8ED803B42}"/>
-          </ac:spMkLst>
-        </pc:spChg>
-      </pc:sldChg>
-      <pc:sldChg chg="modSp mod">
-        <pc:chgData name="Christopher Michael POSKITT" userId="4bd18c9c-05ca-44c7-aeca-cc78c750a47e" providerId="ADAL" clId="{7B141A95-E539-59F1-A1E4-CD0859CEB3EE}" dt="2026-10-26T08:38:47.352" v="427" actId="20577"/>
-        <pc:sldMkLst>
-          <pc:docMk/>
-          <pc:sldMk cId="1262598354" sldId="270"/>
-        </pc:sldMkLst>
-        <pc:spChg chg="mod">
-          <ac:chgData name="Christopher Michael POSKITT" userId="4bd18c9c-05ca-44c7-aeca-cc78c750a47e" providerId="ADAL" clId="{7B141A95-E539-59F1-A1E4-CD0859CEB3EE}" dt="2026-10-26T08:38:24.073" v="417" actId="20577"/>
-          <ac:spMkLst>
-            <pc:docMk/>
-            <pc:sldMk cId="1262598354" sldId="270"/>
-            <ac:spMk id="4" creationId="{A0AA96AF-D918-44A0-6441-E67838EA7511}"/>
-          </ac:spMkLst>
-        </pc:spChg>
-        <pc:spChg chg="mod">
-          <ac:chgData name="Christopher Michael POSKITT" userId="4bd18c9c-05ca-44c7-aeca-cc78c750a47e" providerId="ADAL" clId="{7B141A95-E539-59F1-A1E4-CD0859CEB3EE}" dt="2026-10-26T08:38:38.802" v="422" actId="20577"/>
-          <ac:spMkLst>
-            <pc:docMk/>
-            <pc:sldMk cId="1262598354" sldId="270"/>
-            <ac:spMk id="6" creationId="{9BE95E68-C7E0-C4A8-BBB2-0B57BCA9F82E}"/>
-          </ac:spMkLst>
-        </pc:spChg>
-        <pc:spChg chg="mod">
-          <ac:chgData name="Christopher Michael POSKITT" userId="4bd18c9c-05ca-44c7-aeca-cc78c750a47e" providerId="ADAL" clId="{7B141A95-E539-59F1-A1E4-CD0859CEB3EE}" dt="2026-10-26T08:38:47.352" v="427" actId="20577"/>
-          <ac:spMkLst>
-            <pc:docMk/>
-            <pc:sldMk cId="1262598354" sldId="270"/>
-            <ac:spMk id="9" creationId="{69D81FF1-1C49-9CFC-94A6-52E09B3D2BE9}"/>
-          </ac:spMkLst>
-        </pc:spChg>
-        <pc:spChg chg="mod">
-          <ac:chgData name="Christopher Michael POSKITT" userId="4bd18c9c-05ca-44c7-aeca-cc78c750a47e" providerId="ADAL" clId="{7B141A95-E539-59F1-A1E4-CD0859CEB3EE}" dt="2026-10-26T08:37:48.712" v="407" actId="20577"/>
-          <ac:spMkLst>
-            <pc:docMk/>
-            <pc:sldMk cId="1262598354" sldId="270"/>
-            <ac:spMk id="12" creationId="{621406ED-C52B-6F63-2D8A-D1C9B90F7B4C}"/>
-          </ac:spMkLst>
-        </pc:spChg>
-        <pc:spChg chg="mod">
-          <ac:chgData name="Christopher Michael POSKITT" userId="4bd18c9c-05ca-44c7-aeca-cc78c750a47e" providerId="ADAL" clId="{7B141A95-E539-59F1-A1E4-CD0859CEB3EE}" dt="2026-10-25T16:25:36.416" v="3" actId="13926"/>
-          <ac:spMkLst>
-            <pc:docMk/>
-            <pc:sldMk cId="1262598354" sldId="270"/>
-            <ac:spMk id="14" creationId="{0F9E59B9-8873-DAA9-DB90-DB306448F409}"/>
-          </ac:spMkLst>
-        </pc:spChg>
-      </pc:sldChg>
-      <pc:sldChg chg="modSp mod">
-        <pc:chgData name="Christopher Michael POSKITT" userId="4bd18c9c-05ca-44c7-aeca-cc78c750a47e" providerId="ADAL" clId="{7B141A95-E539-59F1-A1E4-CD0859CEB3EE}" dt="2026-10-26T08:45:14.411" v="654" actId="20577"/>
-        <pc:sldMkLst>
-          <pc:docMk/>
-          <pc:sldMk cId="192733176" sldId="271"/>
-        </pc:sldMkLst>
-        <pc:spChg chg="mod">
-          <ac:chgData name="Christopher Michael POSKITT" userId="4bd18c9c-05ca-44c7-aeca-cc78c750a47e" providerId="ADAL" clId="{7B141A95-E539-59F1-A1E4-CD0859CEB3EE}" dt="2026-10-26T08:45:14.411" v="654" actId="20577"/>
-          <ac:spMkLst>
-            <pc:docMk/>
-            <pc:sldMk cId="192733176" sldId="271"/>
-            <ac:spMk id="4" creationId="{769D1187-DDDA-7E13-D6AA-2E7C7FEEA573}"/>
-          </ac:spMkLst>
-        </pc:spChg>
-        <pc:graphicFrameChg chg="mod modGraphic">
-          <ac:chgData name="Christopher Michael POSKITT" userId="4bd18c9c-05ca-44c7-aeca-cc78c750a47e" providerId="ADAL" clId="{7B141A95-E539-59F1-A1E4-CD0859CEB3EE}" dt="2026-10-26T08:44:32.045" v="584" actId="20577"/>
-          <ac:graphicFrameMkLst>
-            <pc:docMk/>
-            <pc:sldMk cId="192733176" sldId="271"/>
-            <ac:graphicFrameMk id="2" creationId="{EBD23CCC-25B0-50A5-D420-106D3AF20D51}"/>
-          </ac:graphicFrameMkLst>
-        </pc:graphicFrameChg>
-      </pc:sldChg>
-      <pc:sldChg chg="modSp mod">
-        <pc:chgData name="Christopher Michael POSKITT" userId="4bd18c9c-05ca-44c7-aeca-cc78c750a47e" providerId="ADAL" clId="{7B141A95-E539-59F1-A1E4-CD0859CEB3EE}" dt="2026-10-26T08:50:10.745" v="880" actId="14100"/>
-        <pc:sldMkLst>
-          <pc:docMk/>
-          <pc:sldMk cId="1700897261" sldId="272"/>
-        </pc:sldMkLst>
-        <pc:spChg chg="mod">
-          <ac:chgData name="Christopher Michael POSKITT" userId="4bd18c9c-05ca-44c7-aeca-cc78c750a47e" providerId="ADAL" clId="{7B141A95-E539-59F1-A1E4-CD0859CEB3EE}" dt="2026-10-26T08:46:25.796" v="683" actId="20577"/>
-          <ac:spMkLst>
-            <pc:docMk/>
-            <pc:sldMk cId="1700897261" sldId="272"/>
-            <ac:spMk id="6" creationId="{6CA2D952-52D5-9DB8-3BB8-7DBDFD16BB63}"/>
-          </ac:spMkLst>
-        </pc:spChg>
-        <pc:spChg chg="mod">
-          <ac:chgData name="Christopher Michael POSKITT" userId="4bd18c9c-05ca-44c7-aeca-cc78c750a47e" providerId="ADAL" clId="{7B141A95-E539-59F1-A1E4-CD0859CEB3EE}" dt="2026-10-26T08:50:10.745" v="880" actId="14100"/>
-          <ac:spMkLst>
-            <pc:docMk/>
-            <pc:sldMk cId="1700897261" sldId="272"/>
-            <ac:spMk id="9" creationId="{576587D8-F5B6-E2CD-CBF0-E197A2250317}"/>
-          </ac:spMkLst>
-        </pc:spChg>
-      </pc:sldChg>
-      <pc:sldChg chg="modSp mod">
-        <pc:chgData name="Christopher Michael POSKITT" userId="4bd18c9c-05ca-44c7-aeca-cc78c750a47e" providerId="ADAL" clId="{7B141A95-E539-59F1-A1E4-CD0859CEB3EE}" dt="2026-10-26T08:56:10.138" v="1363" actId="20577"/>
-        <pc:sldMkLst>
-          <pc:docMk/>
-          <pc:sldMk cId="803399215" sldId="273"/>
-        </pc:sldMkLst>
-        <pc:spChg chg="mod">
-          <ac:chgData name="Christopher Michael POSKITT" userId="4bd18c9c-05ca-44c7-aeca-cc78c750a47e" providerId="ADAL" clId="{7B141A95-E539-59F1-A1E4-CD0859CEB3EE}" dt="2026-10-26T08:55:47.979" v="1281" actId="1076"/>
-          <ac:spMkLst>
-            <pc:docMk/>
-            <pc:sldMk cId="803399215" sldId="273"/>
-            <ac:spMk id="3" creationId="{A64087E2-7504-89B0-7410-B3910D87F06F}"/>
-          </ac:spMkLst>
-        </pc:spChg>
-        <pc:spChg chg="mod">
-          <ac:chgData name="Christopher Michael POSKITT" userId="4bd18c9c-05ca-44c7-aeca-cc78c750a47e" providerId="ADAL" clId="{7B141A95-E539-59F1-A1E4-CD0859CEB3EE}" dt="2026-10-26T08:56:10.138" v="1363" actId="20577"/>
-          <ac:spMkLst>
-            <pc:docMk/>
-            <pc:sldMk cId="803399215" sldId="273"/>
-            <ac:spMk id="4" creationId="{401011E2-9499-268D-7732-D86CB00DF1F4}"/>
-          </ac:spMkLst>
-        </pc:spChg>
-      </pc:sldChg>
-      <pc:sldChg chg="modSp mod modCm">
-        <pc:chgData name="Christopher Michael POSKITT" userId="4bd18c9c-05ca-44c7-aeca-cc78c750a47e" providerId="ADAL" clId="{7B141A95-E539-59F1-A1E4-CD0859CEB3EE}" dt="2026-10-26T08:55:01.289" v="1234" actId="20577"/>
-        <pc:sldMkLst>
-          <pc:docMk/>
-          <pc:sldMk cId="3674628644" sldId="274"/>
-        </pc:sldMkLst>
-        <pc:graphicFrameChg chg="modGraphic">
-          <ac:chgData name="Christopher Michael POSKITT" userId="4bd18c9c-05ca-44c7-aeca-cc78c750a47e" providerId="ADAL" clId="{7B141A95-E539-59F1-A1E4-CD0859CEB3EE}" dt="2026-10-26T08:55:01.289" v="1234" actId="20577"/>
-          <ac:graphicFrameMkLst>
-            <pc:docMk/>
-            <pc:sldMk cId="3674628644" sldId="274"/>
-            <ac:graphicFrameMk id="2" creationId="{539EA8CD-2DB7-12C9-3AD5-5FCF98B8D6F5}"/>
-          </ac:graphicFrameMkLst>
-        </pc:graphicFrameChg>
-        <pc:extLst>
-          <p:ext xmlns:p="http://schemas.openxmlformats.org/presentationml/2006/main" uri="{D6D511B9-2390-475A-947B-AFAB55BFBCF1}">
-            <pc226:cmChg xmlns:pc226="http://schemas.microsoft.com/office/powerpoint/2022/06/main/command" chg="mod">
-              <pc226:chgData name="Christopher Michael POSKITT" userId="4bd18c9c-05ca-44c7-aeca-cc78c750a47e" providerId="ADAL" clId="{7B141A95-E539-59F1-A1E4-CD0859CEB3EE}" dt="2026-10-26T08:53:04.441" v="1010" actId="20577"/>
-              <pc2:cmMkLst xmlns:pc2="http://schemas.microsoft.com/office/powerpoint/2019/9/main/command">
-                <pc:docMk/>
-                <pc:sldMk cId="3674628644" sldId="274"/>
-                <pc2:cmMk id="{8C286977-3006-A642-9FA2-0C3C928F5E52}"/>
-              </pc2:cmMkLst>
-            </pc226:cmChg>
-          </p:ext>
-        </pc:extLst>
-      </pc:sldChg>
-      <pc:sldChg chg="modSp mod">
-        <pc:chgData name="Christopher Michael POSKITT" userId="4bd18c9c-05ca-44c7-aeca-cc78c750a47e" providerId="ADAL" clId="{7B141A95-E539-59F1-A1E4-CD0859CEB3EE}" dt="2026-10-26T08:56:39.824" v="1366" actId="20577"/>
-        <pc:sldMkLst>
-          <pc:docMk/>
-          <pc:sldMk cId="1179733485" sldId="275"/>
-        </pc:sldMkLst>
-        <pc:spChg chg="mod">
-          <ac:chgData name="Christopher Michael POSKITT" userId="4bd18c9c-05ca-44c7-aeca-cc78c750a47e" providerId="ADAL" clId="{7B141A95-E539-59F1-A1E4-CD0859CEB3EE}" dt="2026-10-26T08:56:39.824" v="1366" actId="20577"/>
-          <ac:spMkLst>
-            <pc:docMk/>
-            <pc:sldMk cId="1179733485" sldId="275"/>
-            <ac:spMk id="13" creationId="{987675FD-A4AB-F30F-3A5D-84521B58D19B}"/>
-          </ac:spMkLst>
-        </pc:spChg>
-      </pc:sldChg>
-      <pc:sldChg chg="modSp mod">
-        <pc:chgData name="Christopher Michael POSKITT" userId="4bd18c9c-05ca-44c7-aeca-cc78c750a47e" providerId="ADAL" clId="{7B141A95-E539-59F1-A1E4-CD0859CEB3EE}" dt="2026-10-26T08:41:57.290" v="493" actId="20577"/>
-        <pc:sldMkLst>
-          <pc:docMk/>
-          <pc:sldMk cId="3706894185" sldId="281"/>
-        </pc:sldMkLst>
-        <pc:spChg chg="mod">
-          <ac:chgData name="Christopher Michael POSKITT" userId="4bd18c9c-05ca-44c7-aeca-cc78c750a47e" providerId="ADAL" clId="{7B141A95-E539-59F1-A1E4-CD0859CEB3EE}" dt="2026-10-26T08:41:57.290" v="493" actId="20577"/>
-          <ac:spMkLst>
-            <pc:docMk/>
-            <pc:sldMk cId="3706894185" sldId="281"/>
-            <ac:spMk id="4" creationId="{BFA8763B-6073-B4C6-8DF9-36B40B39E9F6}"/>
-          </ac:spMkLst>
-        </pc:spChg>
-      </pc:sldChg>
-      <pc:sldChg chg="modSp mod modCm">
-        <pc:chgData name="Christopher Michael POSKITT" userId="4bd18c9c-05ca-44c7-aeca-cc78c750a47e" providerId="ADAL" clId="{7B141A95-E539-59F1-A1E4-CD0859CEB3EE}" dt="2026-10-26T08:39:36.538" v="463" actId="20577"/>
-        <pc:sldMkLst>
-          <pc:docMk/>
-          <pc:sldMk cId="2721407761" sldId="282"/>
-        </pc:sldMkLst>
-        <pc:spChg chg="mod">
-          <ac:chgData name="Christopher Michael POSKITT" userId="4bd18c9c-05ca-44c7-aeca-cc78c750a47e" providerId="ADAL" clId="{7B141A95-E539-59F1-A1E4-CD0859CEB3EE}" dt="2026-10-26T08:39:36.538" v="463" actId="20577"/>
-          <ac:spMkLst>
-            <pc:docMk/>
-            <pc:sldMk cId="2721407761" sldId="282"/>
-            <ac:spMk id="3" creationId="{78A62D57-BEE2-ED31-02BB-39CCC4B64776}"/>
-          </ac:spMkLst>
-        </pc:spChg>
-        <pc:extLst>
-          <p:ext xmlns:p="http://schemas.openxmlformats.org/presentationml/2006/main" uri="{D6D511B9-2390-475A-947B-AFAB55BFBCF1}">
-            <pc226:cmChg xmlns:pc226="http://schemas.microsoft.com/office/powerpoint/2022/06/main/command" chg="mod">
-              <pc226:chgData name="Christopher Michael POSKITT" userId="4bd18c9c-05ca-44c7-aeca-cc78c750a47e" providerId="ADAL" clId="{7B141A95-E539-59F1-A1E4-CD0859CEB3EE}" dt="2026-10-26T08:39:36.538" v="463" actId="20577"/>
-              <pc2:cmMkLst xmlns:pc2="http://schemas.microsoft.com/office/powerpoint/2019/9/main/command">
-                <pc:docMk/>
-                <pc:sldMk cId="2721407761" sldId="282"/>
-                <pc2:cmMk id="{38F8DAF1-A6A7-401F-BAAF-5DAC9564373C}"/>
-              </pc2:cmMkLst>
-            </pc226:cmChg>
-          </p:ext>
-        </pc:extLst>
-      </pc:sldChg>
-      <pc:sldChg chg="modSp mod">
-        <pc:chgData name="Christopher Michael POSKITT" userId="4bd18c9c-05ca-44c7-aeca-cc78c750a47e" providerId="ADAL" clId="{7B141A95-E539-59F1-A1E4-CD0859CEB3EE}" dt="2026-10-26T08:32:54.798" v="246" actId="2165"/>
-        <pc:sldMkLst>
-          <pc:docMk/>
-          <pc:sldMk cId="1111323446" sldId="283"/>
-        </pc:sldMkLst>
-        <pc:graphicFrameChg chg="mod modGraphic">
-          <ac:chgData name="Christopher Michael POSKITT" userId="4bd18c9c-05ca-44c7-aeca-cc78c750a47e" providerId="ADAL" clId="{7B141A95-E539-59F1-A1E4-CD0859CEB3EE}" dt="2026-10-26T08:32:54.798" v="246" actId="2165"/>
-          <ac:graphicFrameMkLst>
-            <pc:docMk/>
-            <pc:sldMk cId="1111323446" sldId="283"/>
-            <ac:graphicFrameMk id="6" creationId="{E0E7A347-10AC-03FB-10E2-56AA362B959B}"/>
-          </ac:graphicFrameMkLst>
-        </pc:graphicFrameChg>
-      </pc:sldChg>
-      <pc:sldChg chg="modSp add mod">
-        <pc:chgData name="Christopher Michael POSKITT" userId="4bd18c9c-05ca-44c7-aeca-cc78c750a47e" providerId="ADAL" clId="{7B141A95-E539-59F1-A1E4-CD0859CEB3EE}" dt="2026-10-26T09:00:08.084" v="1509" actId="20577"/>
-        <pc:sldMkLst>
-          <pc:docMk/>
-          <pc:sldMk cId="2194179436" sldId="285"/>
-        </pc:sldMkLst>
-        <pc:spChg chg="mod">
-          <ac:chgData name="Christopher Michael POSKITT" userId="4bd18c9c-05ca-44c7-aeca-cc78c750a47e" providerId="ADAL" clId="{7B141A95-E539-59F1-A1E4-CD0859CEB3EE}" dt="2026-10-26T09:00:08.084" v="1509" actId="20577"/>
-          <ac:spMkLst>
-            <pc:docMk/>
-            <pc:sldMk cId="2194179436" sldId="285"/>
-            <ac:spMk id="4" creationId="{6313351F-AF89-CE0A-C10A-68A536A990F8}"/>
-          </ac:spMkLst>
-        </pc:spChg>
-        <pc:spChg chg="mod">
-          <ac:chgData name="Christopher Michael POSKITT" userId="4bd18c9c-05ca-44c7-aeca-cc78c750a47e" providerId="ADAL" clId="{7B141A95-E539-59F1-A1E4-CD0859CEB3EE}" dt="2026-10-26T08:59:29.994" v="1385" actId="20577"/>
-          <ac:spMkLst>
-            <pc:docMk/>
-            <pc:sldMk cId="2194179436" sldId="285"/>
-            <ac:spMk id="12" creationId="{8B08CC57-8B55-6D81-5798-9356D8FB6A9A}"/>
-          </ac:spMkLst>
-        </pc:spChg>
-      </pc:sldChg>
-    </pc:docChg>
-  </pc:docChgLst>
-  <pc:docChgLst>
-    <pc:chgData name="Nitendra KUMAR" userId="S::nitendrak@smu.edu.sg::46da4551-a3da-4111-80e7-068ca2c04424" providerId="AD" clId="Web-{CA4A71BA-9058-B71E-ECA4-7CD9AEE9C919}"/>
-    <pc:docChg chg="modSld">
-      <pc:chgData name="Nitendra KUMAR" userId="S::nitendrak@smu.edu.sg::46da4551-a3da-4111-80e7-068ca2c04424" providerId="AD" clId="Web-{CA4A71BA-9058-B71E-ECA4-7CD9AEE9C919}" dt="2026-10-23T07:58:50.455" v="191"/>
-      <pc:docMkLst>
-        <pc:docMk/>
-      </pc:docMkLst>
-      <pc:sldChg chg="modSp">
-        <pc:chgData name="Nitendra KUMAR" userId="S::nitendrak@smu.edu.sg::46da4551-a3da-4111-80e7-068ca2c04424" providerId="AD" clId="Web-{CA4A71BA-9058-B71E-ECA4-7CD9AEE9C919}" dt="2026-10-23T07:58:50.455" v="191"/>
-        <pc:sldMkLst>
-          <pc:docMk/>
-          <pc:sldMk cId="1111323446" sldId="283"/>
-        </pc:sldMkLst>
-        <pc:graphicFrameChg chg="mod modGraphic">
-          <ac:chgData name="Nitendra KUMAR" userId="S::nitendrak@smu.edu.sg::46da4551-a3da-4111-80e7-068ca2c04424" providerId="AD" clId="Web-{CA4A71BA-9058-B71E-ECA4-7CD9AEE9C919}" dt="2026-10-23T07:58:50.455" v="191"/>
-          <ac:graphicFrameMkLst>
-            <pc:docMk/>
-            <pc:sldMk cId="1111323446" sldId="283"/>
-            <ac:graphicFrameMk id="6" creationId="{E0E7A347-10AC-03FB-10E2-56AA362B959B}"/>
-          </ac:graphicFrameMkLst>
-        </pc:graphicFrameChg>
-      </pc:sldChg>
-    </pc:docChg>
-  </pc:docChgLst>
   <pc:docChgLst>
     <pc:chgData name="Ivan TAN Wei Han" userId="S::ivantan@smu.edu.sg::bcdc89b8-56cc-41dd-ba78-e55d4e5121a0" providerId="AD" clId="Web-{B27AD464-C249-7C21-401E-3715E34F184A}"/>
     <pc:docChg chg="modSld">
@@ -525,6 +191,85 @@
             </pc226:cmChg>
           </p:ext>
         </pc:extLst>
+      </pc:sldChg>
+    </pc:docChg>
+  </pc:docChgLst>
+  <pc:docChgLst>
+    <pc:chgData name="Ivan TAN Wei Han" userId="S::ivantan@smu.edu.sg::bcdc89b8-56cc-41dd-ba78-e55d4e5121a0" providerId="AD" clId="Web-{00000000-0000-0000-0000-000000000000}"/>
+    <pc:docChg chg="delSld">
+      <pc:chgData name="Ivan TAN Wei Han" userId="S::ivantan@smu.edu.sg::bcdc89b8-56cc-41dd-ba78-e55d4e5121a0" providerId="AD" clId="Web-{00000000-0000-0000-0000-000000000000}" dt="2026-10-25T07:26:32.648" v="9"/>
+      <pc:docMkLst>
+        <pc:docMk/>
+      </pc:docMkLst>
+      <pc:sldChg chg="del">
+        <pc:chgData name="Ivan TAN Wei Han" userId="S::ivantan@smu.edu.sg::bcdc89b8-56cc-41dd-ba78-e55d4e5121a0" providerId="AD" clId="Web-{00000000-0000-0000-0000-000000000000}" dt="2026-10-25T07:25:58.991" v="0"/>
+        <pc:sldMkLst>
+          <pc:docMk/>
+          <pc:sldMk cId="1501528402" sldId="259"/>
+        </pc:sldMkLst>
+      </pc:sldChg>
+      <pc:sldChg chg="del">
+        <pc:chgData name="Ivan TAN Wei Han" userId="S::ivantan@smu.edu.sg::bcdc89b8-56cc-41dd-ba78-e55d4e5121a0" providerId="AD" clId="Web-{00000000-0000-0000-0000-000000000000}" dt="2026-10-25T07:26:06.491" v="3"/>
+        <pc:sldMkLst>
+          <pc:docMk/>
+          <pc:sldMk cId="3790706018" sldId="260"/>
+        </pc:sldMkLst>
+      </pc:sldChg>
+      <pc:sldChg chg="del">
+        <pc:chgData name="Ivan TAN Wei Han" userId="S::ivantan@smu.edu.sg::bcdc89b8-56cc-41dd-ba78-e55d4e5121a0" providerId="AD" clId="Web-{00000000-0000-0000-0000-000000000000}" dt="2026-10-25T07:26:00.459" v="1"/>
+        <pc:sldMkLst>
+          <pc:docMk/>
+          <pc:sldMk cId="1962571277" sldId="261"/>
+        </pc:sldMkLst>
+      </pc:sldChg>
+      <pc:sldChg chg="del">
+        <pc:chgData name="Ivan TAN Wei Han" userId="S::ivantan@smu.edu.sg::bcdc89b8-56cc-41dd-ba78-e55d4e5121a0" providerId="AD" clId="Web-{00000000-0000-0000-0000-000000000000}" dt="2026-10-25T07:26:10.319" v="4"/>
+        <pc:sldMkLst>
+          <pc:docMk/>
+          <pc:sldMk cId="1054199481" sldId="262"/>
+        </pc:sldMkLst>
+      </pc:sldChg>
+      <pc:sldChg chg="del">
+        <pc:chgData name="Ivan TAN Wei Han" userId="S::ivantan@smu.edu.sg::bcdc89b8-56cc-41dd-ba78-e55d4e5121a0" providerId="AD" clId="Web-{00000000-0000-0000-0000-000000000000}" dt="2026-10-25T07:26:11.491" v="5"/>
+        <pc:sldMkLst>
+          <pc:docMk/>
+          <pc:sldMk cId="3088936750" sldId="263"/>
+        </pc:sldMkLst>
+      </pc:sldChg>
+      <pc:sldChg chg="del">
+        <pc:chgData name="Ivan TAN Wei Han" userId="S::ivantan@smu.edu.sg::bcdc89b8-56cc-41dd-ba78-e55d4e5121a0" providerId="AD" clId="Web-{00000000-0000-0000-0000-000000000000}" dt="2026-10-25T07:26:12.772" v="6"/>
+        <pc:sldMkLst>
+          <pc:docMk/>
+          <pc:sldMk cId="2388298255" sldId="264"/>
+        </pc:sldMkLst>
+      </pc:sldChg>
+      <pc:sldChg chg="del">
+        <pc:chgData name="Ivan TAN Wei Han" userId="S::ivantan@smu.edu.sg::bcdc89b8-56cc-41dd-ba78-e55d4e5121a0" providerId="AD" clId="Web-{00000000-0000-0000-0000-000000000000}" dt="2026-10-25T07:26:14.023" v="7"/>
+        <pc:sldMkLst>
+          <pc:docMk/>
+          <pc:sldMk cId="2055485165" sldId="265"/>
+        </pc:sldMkLst>
+      </pc:sldChg>
+      <pc:sldChg chg="del">
+        <pc:chgData name="Ivan TAN Wei Han" userId="S::ivantan@smu.edu.sg::bcdc89b8-56cc-41dd-ba78-e55d4e5121a0" providerId="AD" clId="Web-{00000000-0000-0000-0000-000000000000}" dt="2026-10-25T07:26:19.054" v="8"/>
+        <pc:sldMkLst>
+          <pc:docMk/>
+          <pc:sldMk cId="3594027622" sldId="268"/>
+        </pc:sldMkLst>
+      </pc:sldChg>
+      <pc:sldChg chg="del">
+        <pc:chgData name="Ivan TAN Wei Han" userId="S::ivantan@smu.edu.sg::bcdc89b8-56cc-41dd-ba78-e55d4e5121a0" providerId="AD" clId="Web-{00000000-0000-0000-0000-000000000000}" dt="2026-10-25T07:26:32.648" v="9"/>
+        <pc:sldMkLst>
+          <pc:docMk/>
+          <pc:sldMk cId="1513630709" sldId="278"/>
+        </pc:sldMkLst>
+      </pc:sldChg>
+      <pc:sldChg chg="del">
+        <pc:chgData name="Ivan TAN Wei Han" userId="S::ivantan@smu.edu.sg::bcdc89b8-56cc-41dd-ba78-e55d4e5121a0" providerId="AD" clId="Web-{00000000-0000-0000-0000-000000000000}" dt="2026-10-25T07:26:05.163" v="2"/>
+        <pc:sldMkLst>
+          <pc:docMk/>
+          <pc:sldMk cId="4252927841" sldId="285"/>
+        </pc:sldMkLst>
       </pc:sldChg>
     </pc:docChg>
   </pc:docChgLst>
@@ -860,81 +605,317 @@
     </pc:docChg>
   </pc:docChgLst>
   <pc:docChgLst>
-    <pc:chgData name="Ivan TAN Wei Han" userId="S::ivantan@smu.edu.sg::bcdc89b8-56cc-41dd-ba78-e55d4e5121a0" providerId="AD" clId="Web-{00000000-0000-0000-0000-000000000000}"/>
-    <pc:docChg chg="delSld">
-      <pc:chgData name="Ivan TAN Wei Han" userId="S::ivantan@smu.edu.sg::bcdc89b8-56cc-41dd-ba78-e55d4e5121a0" providerId="AD" clId="Web-{00000000-0000-0000-0000-000000000000}" dt="2026-10-25T07:26:32.648" v="9"/>
+    <pc:chgData name="Christopher Michael POSKITT" userId="4bd18c9c-05ca-44c7-aeca-cc78c750a47e" providerId="ADAL" clId="{7B141A95-E539-59F1-A1E4-CD0859CEB3EE}"/>
+    <pc:docChg chg="undo custSel addSld modSld">
+      <pc:chgData name="Christopher Michael POSKITT" userId="4bd18c9c-05ca-44c7-aeca-cc78c750a47e" providerId="ADAL" clId="{7B141A95-E539-59F1-A1E4-CD0859CEB3EE}" dt="2026-10-26T09:00:08.084" v="1509" actId="20577"/>
       <pc:docMkLst>
         <pc:docMk/>
       </pc:docMkLst>
-      <pc:sldChg chg="del">
-        <pc:chgData name="Ivan TAN Wei Han" userId="S::ivantan@smu.edu.sg::bcdc89b8-56cc-41dd-ba78-e55d4e5121a0" providerId="AD" clId="Web-{00000000-0000-0000-0000-000000000000}" dt="2026-10-25T07:25:58.991" v="0"/>
+      <pc:sldChg chg="modSp mod">
+        <pc:chgData name="Christopher Michael POSKITT" userId="4bd18c9c-05ca-44c7-aeca-cc78c750a47e" providerId="ADAL" clId="{7B141A95-E539-59F1-A1E4-CD0859CEB3EE}" dt="2026-10-26T08:35:42.890" v="399" actId="20577"/>
         <pc:sldMkLst>
           <pc:docMk/>
-          <pc:sldMk cId="1501528402" sldId="259"/>
+          <pc:sldMk cId="62309270" sldId="258"/>
         </pc:sldMkLst>
+        <pc:spChg chg="mod">
+          <ac:chgData name="Christopher Michael POSKITT" userId="4bd18c9c-05ca-44c7-aeca-cc78c750a47e" providerId="ADAL" clId="{7B141A95-E539-59F1-A1E4-CD0859CEB3EE}" dt="2026-10-26T08:35:42.890" v="399" actId="20577"/>
+          <ac:spMkLst>
+            <pc:docMk/>
+            <pc:sldMk cId="62309270" sldId="258"/>
+            <ac:spMk id="3" creationId="{E7DA8B45-FD63-2AF7-E6C3-CA68DA63B13A}"/>
+          </ac:spMkLst>
+        </pc:spChg>
       </pc:sldChg>
-      <pc:sldChg chg="del">
-        <pc:chgData name="Ivan TAN Wei Han" userId="S::ivantan@smu.edu.sg::bcdc89b8-56cc-41dd-ba78-e55d4e5121a0" providerId="AD" clId="Web-{00000000-0000-0000-0000-000000000000}" dt="2026-10-25T07:26:06.491" v="3"/>
+      <pc:sldChg chg="modSp mod">
+        <pc:chgData name="Christopher Michael POSKITT" userId="4bd18c9c-05ca-44c7-aeca-cc78c750a47e" providerId="ADAL" clId="{7B141A95-E539-59F1-A1E4-CD0859CEB3EE}" dt="2026-10-26T08:34:25.709" v="265" actId="20577"/>
         <pc:sldMkLst>
           <pc:docMk/>
-          <pc:sldMk cId="3790706018" sldId="260"/>
+          <pc:sldMk cId="1394506334" sldId="266"/>
         </pc:sldMkLst>
+        <pc:spChg chg="mod">
+          <ac:chgData name="Christopher Michael POSKITT" userId="4bd18c9c-05ca-44c7-aeca-cc78c750a47e" providerId="ADAL" clId="{7B141A95-E539-59F1-A1E4-CD0859CEB3EE}" dt="2026-10-26T08:34:25.709" v="265" actId="20577"/>
+          <ac:spMkLst>
+            <pc:docMk/>
+            <pc:sldMk cId="1394506334" sldId="266"/>
+            <ac:spMk id="3" creationId="{559B88C5-EAD0-C571-42F7-8A17AE7DAE54}"/>
+          </ac:spMkLst>
+        </pc:spChg>
+        <pc:spChg chg="mod">
+          <ac:chgData name="Christopher Michael POSKITT" userId="4bd18c9c-05ca-44c7-aeca-cc78c750a47e" providerId="ADAL" clId="{7B141A95-E539-59F1-A1E4-CD0859CEB3EE}" dt="2026-10-26T08:33:52.082" v="263" actId="20577"/>
+          <ac:spMkLst>
+            <pc:docMk/>
+            <pc:sldMk cId="1394506334" sldId="266"/>
+            <ac:spMk id="10" creationId="{F394F906-2072-545D-27BE-D172B0E4394F}"/>
+          </ac:spMkLst>
+        </pc:spChg>
       </pc:sldChg>
-      <pc:sldChg chg="del">
-        <pc:chgData name="Ivan TAN Wei Han" userId="S::ivantan@smu.edu.sg::bcdc89b8-56cc-41dd-ba78-e55d4e5121a0" providerId="AD" clId="Web-{00000000-0000-0000-0000-000000000000}" dt="2026-10-25T07:26:00.459" v="1"/>
+      <pc:sldChg chg="modSp mod">
+        <pc:chgData name="Christopher Michael POSKITT" userId="4bd18c9c-05ca-44c7-aeca-cc78c750a47e" providerId="ADAL" clId="{7B141A95-E539-59F1-A1E4-CD0859CEB3EE}" dt="2026-10-26T08:35:03.639" v="273" actId="20577"/>
         <pc:sldMkLst>
           <pc:docMk/>
-          <pc:sldMk cId="1962571277" sldId="261"/>
+          <pc:sldMk cId="1949106433" sldId="267"/>
         </pc:sldMkLst>
+        <pc:spChg chg="mod">
+          <ac:chgData name="Christopher Michael POSKITT" userId="4bd18c9c-05ca-44c7-aeca-cc78c750a47e" providerId="ADAL" clId="{7B141A95-E539-59F1-A1E4-CD0859CEB3EE}" dt="2026-10-26T08:35:03.639" v="273" actId="20577"/>
+          <ac:spMkLst>
+            <pc:docMk/>
+            <pc:sldMk cId="1949106433" sldId="267"/>
+            <ac:spMk id="10" creationId="{723157CC-C155-A981-CD6B-F603456109E5}"/>
+          </ac:spMkLst>
+        </pc:spChg>
       </pc:sldChg>
-      <pc:sldChg chg="del">
-        <pc:chgData name="Ivan TAN Wei Han" userId="S::ivantan@smu.edu.sg::bcdc89b8-56cc-41dd-ba78-e55d4e5121a0" providerId="AD" clId="Web-{00000000-0000-0000-0000-000000000000}" dt="2026-10-25T07:26:10.319" v="4"/>
+      <pc:sldChg chg="modSp mod">
+        <pc:chgData name="Christopher Michael POSKITT" userId="4bd18c9c-05ca-44c7-aeca-cc78c750a47e" providerId="ADAL" clId="{7B141A95-E539-59F1-A1E4-CD0859CEB3EE}" dt="2026-10-26T08:37:51.719" v="411" actId="20577"/>
         <pc:sldMkLst>
           <pc:docMk/>
-          <pc:sldMk cId="1054199481" sldId="262"/>
+          <pc:sldMk cId="2708235050" sldId="269"/>
         </pc:sldMkLst>
+        <pc:spChg chg="mod">
+          <ac:chgData name="Christopher Michael POSKITT" userId="4bd18c9c-05ca-44c7-aeca-cc78c750a47e" providerId="ADAL" clId="{7B141A95-E539-59F1-A1E4-CD0859CEB3EE}" dt="2026-10-26T08:37:51.719" v="411" actId="20577"/>
+          <ac:spMkLst>
+            <pc:docMk/>
+            <pc:sldMk cId="2708235050" sldId="269"/>
+            <ac:spMk id="12" creationId="{EC0C83F2-486B-943F-791A-A1D8ED803B42}"/>
+          </ac:spMkLst>
+        </pc:spChg>
       </pc:sldChg>
-      <pc:sldChg chg="del">
-        <pc:chgData name="Ivan TAN Wei Han" userId="S::ivantan@smu.edu.sg::bcdc89b8-56cc-41dd-ba78-e55d4e5121a0" providerId="AD" clId="Web-{00000000-0000-0000-0000-000000000000}" dt="2026-10-25T07:26:11.491" v="5"/>
+      <pc:sldChg chg="modSp mod">
+        <pc:chgData name="Christopher Michael POSKITT" userId="4bd18c9c-05ca-44c7-aeca-cc78c750a47e" providerId="ADAL" clId="{7B141A95-E539-59F1-A1E4-CD0859CEB3EE}" dt="2026-10-26T08:38:47.352" v="427" actId="20577"/>
         <pc:sldMkLst>
           <pc:docMk/>
-          <pc:sldMk cId="3088936750" sldId="263"/>
+          <pc:sldMk cId="1262598354" sldId="270"/>
         </pc:sldMkLst>
+        <pc:spChg chg="mod">
+          <ac:chgData name="Christopher Michael POSKITT" userId="4bd18c9c-05ca-44c7-aeca-cc78c750a47e" providerId="ADAL" clId="{7B141A95-E539-59F1-A1E4-CD0859CEB3EE}" dt="2026-10-26T08:38:24.073" v="417" actId="20577"/>
+          <ac:spMkLst>
+            <pc:docMk/>
+            <pc:sldMk cId="1262598354" sldId="270"/>
+            <ac:spMk id="4" creationId="{A0AA96AF-D918-44A0-6441-E67838EA7511}"/>
+          </ac:spMkLst>
+        </pc:spChg>
+        <pc:spChg chg="mod">
+          <ac:chgData name="Christopher Michael POSKITT" userId="4bd18c9c-05ca-44c7-aeca-cc78c750a47e" providerId="ADAL" clId="{7B141A95-E539-59F1-A1E4-CD0859CEB3EE}" dt="2026-10-26T08:38:38.802" v="422" actId="20577"/>
+          <ac:spMkLst>
+            <pc:docMk/>
+            <pc:sldMk cId="1262598354" sldId="270"/>
+            <ac:spMk id="6" creationId="{9BE95E68-C7E0-C4A8-BBB2-0B57BCA9F82E}"/>
+          </ac:spMkLst>
+        </pc:spChg>
+        <pc:spChg chg="mod">
+          <ac:chgData name="Christopher Michael POSKITT" userId="4bd18c9c-05ca-44c7-aeca-cc78c750a47e" providerId="ADAL" clId="{7B141A95-E539-59F1-A1E4-CD0859CEB3EE}" dt="2026-10-26T08:38:47.352" v="427" actId="20577"/>
+          <ac:spMkLst>
+            <pc:docMk/>
+            <pc:sldMk cId="1262598354" sldId="270"/>
+            <ac:spMk id="9" creationId="{69D81FF1-1C49-9CFC-94A6-52E09B3D2BE9}"/>
+          </ac:spMkLst>
+        </pc:spChg>
+        <pc:spChg chg="mod">
+          <ac:chgData name="Christopher Michael POSKITT" userId="4bd18c9c-05ca-44c7-aeca-cc78c750a47e" providerId="ADAL" clId="{7B141A95-E539-59F1-A1E4-CD0859CEB3EE}" dt="2026-10-26T08:37:48.712" v="407" actId="20577"/>
+          <ac:spMkLst>
+            <pc:docMk/>
+            <pc:sldMk cId="1262598354" sldId="270"/>
+            <ac:spMk id="12" creationId="{621406ED-C52B-6F63-2D8A-D1C9B90F7B4C}"/>
+          </ac:spMkLst>
+        </pc:spChg>
+        <pc:spChg chg="mod">
+          <ac:chgData name="Christopher Michael POSKITT" userId="4bd18c9c-05ca-44c7-aeca-cc78c750a47e" providerId="ADAL" clId="{7B141A95-E539-59F1-A1E4-CD0859CEB3EE}" dt="2026-10-25T16:25:36.416" v="3" actId="13926"/>
+          <ac:spMkLst>
+            <pc:docMk/>
+            <pc:sldMk cId="1262598354" sldId="270"/>
+            <ac:spMk id="14" creationId="{0F9E59B9-8873-DAA9-DB90-DB306448F409}"/>
+          </ac:spMkLst>
+        </pc:spChg>
       </pc:sldChg>
-      <pc:sldChg chg="del">
-        <pc:chgData name="Ivan TAN Wei Han" userId="S::ivantan@smu.edu.sg::bcdc89b8-56cc-41dd-ba78-e55d4e5121a0" providerId="AD" clId="Web-{00000000-0000-0000-0000-000000000000}" dt="2026-10-25T07:26:12.772" v="6"/>
+      <pc:sldChg chg="modSp mod">
+        <pc:chgData name="Christopher Michael POSKITT" userId="4bd18c9c-05ca-44c7-aeca-cc78c750a47e" providerId="ADAL" clId="{7B141A95-E539-59F1-A1E4-CD0859CEB3EE}" dt="2026-10-26T08:45:14.411" v="654" actId="20577"/>
         <pc:sldMkLst>
           <pc:docMk/>
-          <pc:sldMk cId="2388298255" sldId="264"/>
+          <pc:sldMk cId="192733176" sldId="271"/>
         </pc:sldMkLst>
+        <pc:spChg chg="mod">
+          <ac:chgData name="Christopher Michael POSKITT" userId="4bd18c9c-05ca-44c7-aeca-cc78c750a47e" providerId="ADAL" clId="{7B141A95-E539-59F1-A1E4-CD0859CEB3EE}" dt="2026-10-26T08:45:14.411" v="654" actId="20577"/>
+          <ac:spMkLst>
+            <pc:docMk/>
+            <pc:sldMk cId="192733176" sldId="271"/>
+            <ac:spMk id="4" creationId="{769D1187-DDDA-7E13-D6AA-2E7C7FEEA573}"/>
+          </ac:spMkLst>
+        </pc:spChg>
+        <pc:graphicFrameChg chg="mod modGraphic">
+          <ac:chgData name="Christopher Michael POSKITT" userId="4bd18c9c-05ca-44c7-aeca-cc78c750a47e" providerId="ADAL" clId="{7B141A95-E539-59F1-A1E4-CD0859CEB3EE}" dt="2026-10-26T08:44:32.045" v="584" actId="20577"/>
+          <ac:graphicFrameMkLst>
+            <pc:docMk/>
+            <pc:sldMk cId="192733176" sldId="271"/>
+            <ac:graphicFrameMk id="2" creationId="{EBD23CCC-25B0-50A5-D420-106D3AF20D51}"/>
+          </ac:graphicFrameMkLst>
+        </pc:graphicFrameChg>
       </pc:sldChg>
-      <pc:sldChg chg="del">
-        <pc:chgData name="Ivan TAN Wei Han" userId="S::ivantan@smu.edu.sg::bcdc89b8-56cc-41dd-ba78-e55d4e5121a0" providerId="AD" clId="Web-{00000000-0000-0000-0000-000000000000}" dt="2026-10-25T07:26:14.023" v="7"/>
+      <pc:sldChg chg="modSp mod">
+        <pc:chgData name="Christopher Michael POSKITT" userId="4bd18c9c-05ca-44c7-aeca-cc78c750a47e" providerId="ADAL" clId="{7B141A95-E539-59F1-A1E4-CD0859CEB3EE}" dt="2026-10-26T08:50:10.745" v="880" actId="14100"/>
         <pc:sldMkLst>
           <pc:docMk/>
-          <pc:sldMk cId="2055485165" sldId="265"/>
+          <pc:sldMk cId="1700897261" sldId="272"/>
         </pc:sldMkLst>
+        <pc:spChg chg="mod">
+          <ac:chgData name="Christopher Michael POSKITT" userId="4bd18c9c-05ca-44c7-aeca-cc78c750a47e" providerId="ADAL" clId="{7B141A95-E539-59F1-A1E4-CD0859CEB3EE}" dt="2026-10-26T08:46:25.796" v="683" actId="20577"/>
+          <ac:spMkLst>
+            <pc:docMk/>
+            <pc:sldMk cId="1700897261" sldId="272"/>
+            <ac:spMk id="6" creationId="{6CA2D952-52D5-9DB8-3BB8-7DBDFD16BB63}"/>
+          </ac:spMkLst>
+        </pc:spChg>
+        <pc:spChg chg="mod">
+          <ac:chgData name="Christopher Michael POSKITT" userId="4bd18c9c-05ca-44c7-aeca-cc78c750a47e" providerId="ADAL" clId="{7B141A95-E539-59F1-A1E4-CD0859CEB3EE}" dt="2026-10-26T08:50:10.745" v="880" actId="14100"/>
+          <ac:spMkLst>
+            <pc:docMk/>
+            <pc:sldMk cId="1700897261" sldId="272"/>
+            <ac:spMk id="9" creationId="{576587D8-F5B6-E2CD-CBF0-E197A2250317}"/>
+          </ac:spMkLst>
+        </pc:spChg>
       </pc:sldChg>
-      <pc:sldChg chg="del">
-        <pc:chgData name="Ivan TAN Wei Han" userId="S::ivantan@smu.edu.sg::bcdc89b8-56cc-41dd-ba78-e55d4e5121a0" providerId="AD" clId="Web-{00000000-0000-0000-0000-000000000000}" dt="2026-10-25T07:26:19.054" v="8"/>
+      <pc:sldChg chg="modSp mod">
+        <pc:chgData name="Christopher Michael POSKITT" userId="4bd18c9c-05ca-44c7-aeca-cc78c750a47e" providerId="ADAL" clId="{7B141A95-E539-59F1-A1E4-CD0859CEB3EE}" dt="2026-10-26T08:56:10.138" v="1363" actId="20577"/>
         <pc:sldMkLst>
           <pc:docMk/>
-          <pc:sldMk cId="3594027622" sldId="268"/>
+          <pc:sldMk cId="803399215" sldId="273"/>
         </pc:sldMkLst>
+        <pc:spChg chg="mod">
+          <ac:chgData name="Christopher Michael POSKITT" userId="4bd18c9c-05ca-44c7-aeca-cc78c750a47e" providerId="ADAL" clId="{7B141A95-E539-59F1-A1E4-CD0859CEB3EE}" dt="2026-10-26T08:55:47.979" v="1281" actId="1076"/>
+          <ac:spMkLst>
+            <pc:docMk/>
+            <pc:sldMk cId="803399215" sldId="273"/>
+            <ac:spMk id="3" creationId="{A64087E2-7504-89B0-7410-B3910D87F06F}"/>
+          </ac:spMkLst>
+        </pc:spChg>
+        <pc:spChg chg="mod">
+          <ac:chgData name="Christopher Michael POSKITT" userId="4bd18c9c-05ca-44c7-aeca-cc78c750a47e" providerId="ADAL" clId="{7B141A95-E539-59F1-A1E4-CD0859CEB3EE}" dt="2026-10-26T08:56:10.138" v="1363" actId="20577"/>
+          <ac:spMkLst>
+            <pc:docMk/>
+            <pc:sldMk cId="803399215" sldId="273"/>
+            <ac:spMk id="4" creationId="{401011E2-9499-268D-7732-D86CB00DF1F4}"/>
+          </ac:spMkLst>
+        </pc:spChg>
       </pc:sldChg>
-      <pc:sldChg chg="del">
-        <pc:chgData name="Ivan TAN Wei Han" userId="S::ivantan@smu.edu.sg::bcdc89b8-56cc-41dd-ba78-e55d4e5121a0" providerId="AD" clId="Web-{00000000-0000-0000-0000-000000000000}" dt="2026-10-25T07:26:32.648" v="9"/>
+      <pc:sldChg chg="modSp mod modCm">
+        <pc:chgData name="Christopher Michael POSKITT" userId="4bd18c9c-05ca-44c7-aeca-cc78c750a47e" providerId="ADAL" clId="{7B141A95-E539-59F1-A1E4-CD0859CEB3EE}" dt="2026-10-26T08:55:01.289" v="1234" actId="20577"/>
         <pc:sldMkLst>
           <pc:docMk/>
-          <pc:sldMk cId="1513630709" sldId="278"/>
+          <pc:sldMk cId="3674628644" sldId="274"/>
         </pc:sldMkLst>
+        <pc:graphicFrameChg chg="modGraphic">
+          <ac:chgData name="Christopher Michael POSKITT" userId="4bd18c9c-05ca-44c7-aeca-cc78c750a47e" providerId="ADAL" clId="{7B141A95-E539-59F1-A1E4-CD0859CEB3EE}" dt="2026-10-26T08:55:01.289" v="1234" actId="20577"/>
+          <ac:graphicFrameMkLst>
+            <pc:docMk/>
+            <pc:sldMk cId="3674628644" sldId="274"/>
+            <ac:graphicFrameMk id="2" creationId="{539EA8CD-2DB7-12C9-3AD5-5FCF98B8D6F5}"/>
+          </ac:graphicFrameMkLst>
+        </pc:graphicFrameChg>
+        <pc:extLst>
+          <p:ext xmlns:p="http://schemas.openxmlformats.org/presentationml/2006/main" uri="{D6D511B9-2390-475A-947B-AFAB55BFBCF1}">
+            <pc226:cmChg xmlns:pc226="http://schemas.microsoft.com/office/powerpoint/2022/06/main/command" chg="mod">
+              <pc226:chgData name="Christopher Michael POSKITT" userId="4bd18c9c-05ca-44c7-aeca-cc78c750a47e" providerId="ADAL" clId="{7B141A95-E539-59F1-A1E4-CD0859CEB3EE}" dt="2026-10-26T08:53:04.441" v="1010" actId="20577"/>
+              <pc2:cmMkLst xmlns:pc2="http://schemas.microsoft.com/office/powerpoint/2019/9/main/command">
+                <pc:docMk/>
+                <pc:sldMk cId="3674628644" sldId="274"/>
+                <pc2:cmMk id="{8C286977-3006-A642-9FA2-0C3C928F5E52}"/>
+              </pc2:cmMkLst>
+            </pc226:cmChg>
+          </p:ext>
+        </pc:extLst>
       </pc:sldChg>
-      <pc:sldChg chg="del">
-        <pc:chgData name="Ivan TAN Wei Han" userId="S::ivantan@smu.edu.sg::bcdc89b8-56cc-41dd-ba78-e55d4e5121a0" providerId="AD" clId="Web-{00000000-0000-0000-0000-000000000000}" dt="2026-10-25T07:26:05.163" v="2"/>
+      <pc:sldChg chg="modSp mod">
+        <pc:chgData name="Christopher Michael POSKITT" userId="4bd18c9c-05ca-44c7-aeca-cc78c750a47e" providerId="ADAL" clId="{7B141A95-E539-59F1-A1E4-CD0859CEB3EE}" dt="2026-10-26T08:56:39.824" v="1366" actId="20577"/>
         <pc:sldMkLst>
           <pc:docMk/>
-          <pc:sldMk cId="4252927841" sldId="285"/>
+          <pc:sldMk cId="1179733485" sldId="275"/>
         </pc:sldMkLst>
+        <pc:spChg chg="mod">
+          <ac:chgData name="Christopher Michael POSKITT" userId="4bd18c9c-05ca-44c7-aeca-cc78c750a47e" providerId="ADAL" clId="{7B141A95-E539-59F1-A1E4-CD0859CEB3EE}" dt="2026-10-26T08:56:39.824" v="1366" actId="20577"/>
+          <ac:spMkLst>
+            <pc:docMk/>
+            <pc:sldMk cId="1179733485" sldId="275"/>
+            <ac:spMk id="13" creationId="{987675FD-A4AB-F30F-3A5D-84521B58D19B}"/>
+          </ac:spMkLst>
+        </pc:spChg>
+      </pc:sldChg>
+      <pc:sldChg chg="modSp mod">
+        <pc:chgData name="Christopher Michael POSKITT" userId="4bd18c9c-05ca-44c7-aeca-cc78c750a47e" providerId="ADAL" clId="{7B141A95-E539-59F1-A1E4-CD0859CEB3EE}" dt="2026-10-26T08:41:57.290" v="493" actId="20577"/>
+        <pc:sldMkLst>
+          <pc:docMk/>
+          <pc:sldMk cId="3706894185" sldId="281"/>
+        </pc:sldMkLst>
+        <pc:spChg chg="mod">
+          <ac:chgData name="Christopher Michael POSKITT" userId="4bd18c9c-05ca-44c7-aeca-cc78c750a47e" providerId="ADAL" clId="{7B141A95-E539-59F1-A1E4-CD0859CEB3EE}" dt="2026-10-26T08:41:57.290" v="493" actId="20577"/>
+          <ac:spMkLst>
+            <pc:docMk/>
+            <pc:sldMk cId="3706894185" sldId="281"/>
+            <ac:spMk id="4" creationId="{BFA8763B-6073-B4C6-8DF9-36B40B39E9F6}"/>
+          </ac:spMkLst>
+        </pc:spChg>
+      </pc:sldChg>
+      <pc:sldChg chg="modSp mod modCm">
+        <pc:chgData name="Christopher Michael POSKITT" userId="4bd18c9c-05ca-44c7-aeca-cc78c750a47e" providerId="ADAL" clId="{7B141A95-E539-59F1-A1E4-CD0859CEB3EE}" dt="2026-10-26T08:39:36.538" v="463" actId="20577"/>
+        <pc:sldMkLst>
+          <pc:docMk/>
+          <pc:sldMk cId="2721407761" sldId="282"/>
+        </pc:sldMkLst>
+        <pc:spChg chg="mod">
+          <ac:chgData name="Christopher Michael POSKITT" userId="4bd18c9c-05ca-44c7-aeca-cc78c750a47e" providerId="ADAL" clId="{7B141A95-E539-59F1-A1E4-CD0859CEB3EE}" dt="2026-10-26T08:39:36.538" v="463" actId="20577"/>
+          <ac:spMkLst>
+            <pc:docMk/>
+            <pc:sldMk cId="2721407761" sldId="282"/>
+            <ac:spMk id="3" creationId="{78A62D57-BEE2-ED31-02BB-39CCC4B64776}"/>
+          </ac:spMkLst>
+        </pc:spChg>
+        <pc:extLst>
+          <p:ext xmlns:p="http://schemas.openxmlformats.org/presentationml/2006/main" uri="{D6D511B9-2390-475A-947B-AFAB55BFBCF1}">
+            <pc226:cmChg xmlns:pc226="http://schemas.microsoft.com/office/powerpoint/2022/06/main/command" chg="mod">
+              <pc226:chgData name="Christopher Michael POSKITT" userId="4bd18c9c-05ca-44c7-aeca-cc78c750a47e" providerId="ADAL" clId="{7B141A95-E539-59F1-A1E4-CD0859CEB3EE}" dt="2026-10-26T08:39:36.538" v="463" actId="20577"/>
+              <pc2:cmMkLst xmlns:pc2="http://schemas.microsoft.com/office/powerpoint/2019/9/main/command">
+                <pc:docMk/>
+                <pc:sldMk cId="2721407761" sldId="282"/>
+                <pc2:cmMk id="{38F8DAF1-A6A7-401F-BAAF-5DAC9564373C}"/>
+              </pc2:cmMkLst>
+            </pc226:cmChg>
+          </p:ext>
+        </pc:extLst>
+      </pc:sldChg>
+      <pc:sldChg chg="modSp mod">
+        <pc:chgData name="Christopher Michael POSKITT" userId="4bd18c9c-05ca-44c7-aeca-cc78c750a47e" providerId="ADAL" clId="{7B141A95-E539-59F1-A1E4-CD0859CEB3EE}" dt="2026-10-26T08:32:54.798" v="246" actId="2165"/>
+        <pc:sldMkLst>
+          <pc:docMk/>
+          <pc:sldMk cId="1111323446" sldId="283"/>
+        </pc:sldMkLst>
+        <pc:graphicFrameChg chg="mod modGraphic">
+          <ac:chgData name="Christopher Michael POSKITT" userId="4bd18c9c-05ca-44c7-aeca-cc78c750a47e" providerId="ADAL" clId="{7B141A95-E539-59F1-A1E4-CD0859CEB3EE}" dt="2026-10-26T08:32:54.798" v="246" actId="2165"/>
+          <ac:graphicFrameMkLst>
+            <pc:docMk/>
+            <pc:sldMk cId="1111323446" sldId="283"/>
+            <ac:graphicFrameMk id="6" creationId="{E0E7A347-10AC-03FB-10E2-56AA362B959B}"/>
+          </ac:graphicFrameMkLst>
+        </pc:graphicFrameChg>
+      </pc:sldChg>
+      <pc:sldChg chg="modSp add mod">
+        <pc:chgData name="Christopher Michael POSKITT" userId="4bd18c9c-05ca-44c7-aeca-cc78c750a47e" providerId="ADAL" clId="{7B141A95-E539-59F1-A1E4-CD0859CEB3EE}" dt="2026-10-26T09:00:08.084" v="1509" actId="20577"/>
+        <pc:sldMkLst>
+          <pc:docMk/>
+          <pc:sldMk cId="2194179436" sldId="285"/>
+        </pc:sldMkLst>
+        <pc:spChg chg="mod">
+          <ac:chgData name="Christopher Michael POSKITT" userId="4bd18c9c-05ca-44c7-aeca-cc78c750a47e" providerId="ADAL" clId="{7B141A95-E539-59F1-A1E4-CD0859CEB3EE}" dt="2026-10-26T09:00:08.084" v="1509" actId="20577"/>
+          <ac:spMkLst>
+            <pc:docMk/>
+            <pc:sldMk cId="2194179436" sldId="285"/>
+            <ac:spMk id="4" creationId="{6313351F-AF89-CE0A-C10A-68A536A990F8}"/>
+          </ac:spMkLst>
+        </pc:spChg>
+        <pc:spChg chg="mod">
+          <ac:chgData name="Christopher Michael POSKITT" userId="4bd18c9c-05ca-44c7-aeca-cc78c750a47e" providerId="ADAL" clId="{7B141A95-E539-59F1-A1E4-CD0859CEB3EE}" dt="2026-10-26T08:59:29.994" v="1385" actId="20577"/>
+          <ac:spMkLst>
+            <pc:docMk/>
+            <pc:sldMk cId="2194179436" sldId="285"/>
+            <ac:spMk id="12" creationId="{8B08CC57-8B55-6D81-5798-9356D8FB6A9A}"/>
+          </ac:spMkLst>
+        </pc:spChg>
       </pc:sldChg>
     </pc:docChg>
   </pc:docChgLst>
@@ -948,26 +929,26 @@
     </pc:docChg>
   </pc:docChgLst>
   <pc:docChgLst>
-    <pc:chgData name="Rajesh Krishna BALAN" userId="S::rajesh@smu.edu.sg::18290a93-1287-40e3-b20f-c7f59a18016f" providerId="AD" clId="Web-{2C526B42-2572-7969-4B37-D57B9DE3D8C6}"/>
+    <pc:chgData name="Nitendra KUMAR" userId="S::nitendrak@smu.edu.sg::46da4551-a3da-4111-80e7-068ca2c04424" providerId="AD" clId="Web-{CA4A71BA-9058-B71E-ECA4-7CD9AEE9C919}"/>
     <pc:docChg chg="modSld">
-      <pc:chgData name="Rajesh Krishna BALAN" userId="S::rajesh@smu.edu.sg::18290a93-1287-40e3-b20f-c7f59a18016f" providerId="AD" clId="Web-{2C526B42-2572-7969-4B37-D57B9DE3D8C6}" dt="2026-10-26T08:34:45.444" v="2" actId="14100"/>
+      <pc:chgData name="Nitendra KUMAR" userId="S::nitendrak@smu.edu.sg::46da4551-a3da-4111-80e7-068ca2c04424" providerId="AD" clId="Web-{CA4A71BA-9058-B71E-ECA4-7CD9AEE9C919}" dt="2026-10-23T07:58:50.455" v="191"/>
       <pc:docMkLst>
         <pc:docMk/>
       </pc:docMkLst>
       <pc:sldChg chg="modSp">
-        <pc:chgData name="Rajesh Krishna BALAN" userId="S::rajesh@smu.edu.sg::18290a93-1287-40e3-b20f-c7f59a18016f" providerId="AD" clId="Web-{2C526B42-2572-7969-4B37-D57B9DE3D8C6}" dt="2026-10-26T08:34:45.444" v="2" actId="14100"/>
+        <pc:chgData name="Nitendra KUMAR" userId="S::nitendrak@smu.edu.sg::46da4551-a3da-4111-80e7-068ca2c04424" providerId="AD" clId="Web-{CA4A71BA-9058-B71E-ECA4-7CD9AEE9C919}" dt="2026-10-23T07:58:50.455" v="191"/>
         <pc:sldMkLst>
           <pc:docMk/>
-          <pc:sldMk cId="1394506334" sldId="266"/>
+          <pc:sldMk cId="1111323446" sldId="283"/>
         </pc:sldMkLst>
-        <pc:spChg chg="mod">
-          <ac:chgData name="Rajesh Krishna BALAN" userId="S::rajesh@smu.edu.sg::18290a93-1287-40e3-b20f-c7f59a18016f" providerId="AD" clId="Web-{2C526B42-2572-7969-4B37-D57B9DE3D8C6}" dt="2026-10-26T08:34:45.444" v="2" actId="14100"/>
-          <ac:spMkLst>
+        <pc:graphicFrameChg chg="mod modGraphic">
+          <ac:chgData name="Nitendra KUMAR" userId="S::nitendrak@smu.edu.sg::46da4551-a3da-4111-80e7-068ca2c04424" providerId="AD" clId="Web-{CA4A71BA-9058-B71E-ECA4-7CD9AEE9C919}" dt="2026-10-23T07:58:50.455" v="191"/>
+          <ac:graphicFrameMkLst>
             <pc:docMk/>
-            <pc:sldMk cId="1394506334" sldId="266"/>
-            <ac:spMk id="9" creationId="{3C05F446-7E48-C388-5966-4A32DBE5EBCE}"/>
-          </ac:spMkLst>
-        </pc:spChg>
+            <pc:sldMk cId="1111323446" sldId="283"/>
+            <ac:graphicFrameMk id="6" creationId="{E0E7A347-10AC-03FB-10E2-56AA362B959B}"/>
+          </ac:graphicFrameMkLst>
+        </pc:graphicFrameChg>
       </pc:sldChg>
     </pc:docChg>
   </pc:docChgLst>
@@ -1131,6 +1112,30 @@
       </pc:sldChg>
     </pc:docChg>
   </pc:docChgLst>
+  <pc:docChgLst>
+    <pc:chgData name="Rajesh Krishna BALAN" userId="S::rajesh@smu.edu.sg::18290a93-1287-40e3-b20f-c7f59a18016f" providerId="AD" clId="Web-{2C526B42-2572-7969-4B37-D57B9DE3D8C6}"/>
+    <pc:docChg chg="modSld">
+      <pc:chgData name="Rajesh Krishna BALAN" userId="S::rajesh@smu.edu.sg::18290a93-1287-40e3-b20f-c7f59a18016f" providerId="AD" clId="Web-{2C526B42-2572-7969-4B37-D57B9DE3D8C6}" dt="2026-10-26T08:34:45.444" v="2" actId="14100"/>
+      <pc:docMkLst>
+        <pc:docMk/>
+      </pc:docMkLst>
+      <pc:sldChg chg="modSp">
+        <pc:chgData name="Rajesh Krishna BALAN" userId="S::rajesh@smu.edu.sg::18290a93-1287-40e3-b20f-c7f59a18016f" providerId="AD" clId="Web-{2C526B42-2572-7969-4B37-D57B9DE3D8C6}" dt="2026-10-26T08:34:45.444" v="2" actId="14100"/>
+        <pc:sldMkLst>
+          <pc:docMk/>
+          <pc:sldMk cId="1394506334" sldId="266"/>
+        </pc:sldMkLst>
+        <pc:spChg chg="mod">
+          <ac:chgData name="Rajesh Krishna BALAN" userId="S::rajesh@smu.edu.sg::18290a93-1287-40e3-b20f-c7f59a18016f" providerId="AD" clId="Web-{2C526B42-2572-7969-4B37-D57B9DE3D8C6}" dt="2026-10-26T08:34:45.444" v="2" actId="14100"/>
+          <ac:spMkLst>
+            <pc:docMk/>
+            <pc:sldMk cId="1394506334" sldId="266"/>
+            <ac:spMk id="9" creationId="{3C05F446-7E48-C388-5966-4A32DBE5EBCE}"/>
+          </ac:spMkLst>
+        </pc:spChg>
+      </pc:sldChg>
+    </pc:docChg>
+  </pc:docChgLst>
 </pc:chgInfo>
 </file>
 
@@ -1216,7 +1221,7 @@
           <a:p>
             <a:fld id="{FAA46ED6-AC80-4E9E-9326-F4554046674A}" type="datetimeFigureOut">
               <a:rPr lang="en-US" smtClean="0"/>
-              <a:t>10/26/26</a:t>
+              <a:t>10/30/2026</a:t>
             </a:fld>
             <a:endParaRPr lang="en-US"/>
           </a:p>
@@ -1612,7 +1617,7 @@
           <a:p>
             <a:fld id="{9CB35AC7-6991-4DF6-9B8D-80726AB1065E}" type="datetimeFigureOut">
               <a:rPr lang="en-US" smtClean="0"/>
-              <a:t>10/26/26</a:t>
+              <a:t>10/30/2026</a:t>
             </a:fld>
             <a:endParaRPr lang="en-US"/>
           </a:p>
@@ -1839,7 +1844,7 @@
           <a:p>
             <a:fld id="{9CB35AC7-6991-4DF6-9B8D-80726AB1065E}" type="datetimeFigureOut">
               <a:rPr lang="en-US" smtClean="0"/>
-              <a:t>10/26/26</a:t>
+              <a:t>10/30/2026</a:t>
             </a:fld>
             <a:endParaRPr lang="en-US"/>
           </a:p>
@@ -2017,7 +2022,7 @@
           <a:p>
             <a:fld id="{9CB35AC7-6991-4DF6-9B8D-80726AB1065E}" type="datetimeFigureOut">
               <a:rPr lang="en-US" smtClean="0"/>
-              <a:t>10/26/26</a:t>
+              <a:t>10/30/2026</a:t>
             </a:fld>
             <a:endParaRPr lang="en-US"/>
           </a:p>
@@ -2591,7 +2596,7 @@
           <a:p>
             <a:fld id="{9CB35AC7-6991-4DF6-9B8D-80726AB1065E}" type="datetimeFigureOut">
               <a:rPr lang="en-US" smtClean="0"/>
-              <a:t>10/26/26</a:t>
+              <a:t>10/30/2026</a:t>
             </a:fld>
             <a:endParaRPr lang="en-US"/>
           </a:p>
@@ -2732,7 +2737,7 @@
           <a:p>
             <a:fld id="{9CB35AC7-6991-4DF6-9B8D-80726AB1065E}" type="datetimeFigureOut">
               <a:rPr lang="en-US" smtClean="0"/>
-              <a:t>10/26/26</a:t>
+              <a:t>10/30/2026</a:t>
             </a:fld>
             <a:endParaRPr lang="en-US"/>
           </a:p>
@@ -2827,7 +2832,7 @@
           <a:p>
             <a:fld id="{9CB35AC7-6991-4DF6-9B8D-80726AB1065E}" type="datetimeFigureOut">
               <a:rPr lang="en-US" smtClean="0"/>
-              <a:t>10/26/26</a:t>
+              <a:t>10/30/2026</a:t>
             </a:fld>
             <a:endParaRPr lang="en-US"/>
           </a:p>
@@ -3102,7 +3107,7 @@
           <a:p>
             <a:fld id="{9CB35AC7-6991-4DF6-9B8D-80726AB1065E}" type="datetimeFigureOut">
               <a:rPr lang="en-US" smtClean="0"/>
-              <a:t>10/26/26</a:t>
+              <a:t>10/30/2026</a:t>
             </a:fld>
             <a:endParaRPr lang="en-US"/>
           </a:p>
@@ -3354,7 +3359,7 @@
           <a:p>
             <a:fld id="{9CB35AC7-6991-4DF6-9B8D-80726AB1065E}" type="datetimeFigureOut">
               <a:rPr lang="en-US" smtClean="0"/>
-              <a:t>10/26/26</a:t>
+              <a:t>10/30/2026</a:t>
             </a:fld>
             <a:endParaRPr lang="en-US"/>
           </a:p>
@@ -3565,7 +3570,7 @@
           <a:p>
             <a:fld id="{9CB35AC7-6991-4DF6-9B8D-80726AB1065E}" type="datetimeFigureOut">
               <a:rPr lang="en-US" smtClean="0"/>
-              <a:t>10/26/26</a:t>
+              <a:t>10/30/2026</a:t>
             </a:fld>
             <a:endParaRPr lang="en-US"/>
           </a:p>
@@ -4252,13 +4257,13 @@
           <p:nvPr>
             <p:extLst>
               <p:ext uri="{D42A27DB-BD31-4B8C-83A1-F6EECF244321}">
-                <p14:modId xmlns:p14="http://schemas.microsoft.com/office/powerpoint/2010/main" val="1119944281"/>
+                <p14:modId xmlns:p14="http://schemas.microsoft.com/office/powerpoint/2010/main" val="4175674539"/>
               </p:ext>
             </p:extLst>
           </p:nvPr>
         </p:nvGraphicFramePr>
         <p:xfrm>
-          <a:off x="326571" y="1939670"/>
+          <a:off x="326571" y="1926511"/>
           <a:ext cx="11538858" cy="3657600"/>
         </p:xfrm>
         <a:graphic>
@@ -4624,7 +4629,7 @@
                         <a:defRPr sz="1000"/>
                       </a:pPr>
                       <a:r>
-                        <a:t>Pass - 16/16 checks green on main (29 Oct 2026)</a:t>
+                        <a:t>Pass - 20/20 check runs green on main eab9f898 (29 Oct 2026)</a:t>
                       </a:r>
                     </a:p>
                   </a:txBody>
@@ -4693,8 +4698,8 @@
         </p:nvSpPr>
         <p:spPr>
           <a:xfrm>
-            <a:off x="326571" y="6251252"/>
-            <a:ext cx="11582403" cy="369332"/>
+            <a:off x="326571" y="4886643"/>
+            <a:ext cx="11582403" cy="830997"/>
           </a:xfrm>
           <a:prstGeom prst="rect">
             <a:avLst/>
@@ -4716,12 +4721,14 @@
               <a:defRPr sz="1200"/>
             </a:pPr>
             <a:r>
+              <a:rPr sz="1200"/>
               <a:t>Overly-isolated Mock-Only Unit Tests:</a:t>
             </a:r>
           </a:p>
           <a:p>
             <a:r>
-              <a:t>Unit tests that heavily mocked the database layer and external browser events provided the least practical value. They often passed even when underlying SQL column types mismatched or when DOM focus transitions failed in real browsers. Value dramatically increased when we shifted towards integration tests with rollback transactions and Playwright browser tests.</a:t>
+              <a:rPr sz="1200"/>
+              <a:t>Unit tests that heavily mocked the database layer and external browser events provided the least practical value. A mocked query cannot notice that the real schema has moved on; in #355 only the real-PostgreSQL suite caught a missing column. Value increased as we added integration tests with rollback transactions and Playwright browser tests.</a:t>
             </a:r>
           </a:p>
         </p:txBody>
@@ -4740,7 +4747,7 @@
         </p:nvSpPr>
         <p:spPr>
           <a:xfrm>
-            <a:off x="326571" y="5788664"/>
+            <a:off x="326571" y="4441111"/>
             <a:ext cx="11201402" cy="369332"/>
           </a:xfrm>
           <a:prstGeom prst="rect">
@@ -4937,8 +4944,8 @@
         </p:nvSpPr>
         <p:spPr>
           <a:xfrm>
-            <a:off x="258537" y="2100552"/>
-            <a:ext cx="11582403" cy="1200329"/>
+            <a:off x="258537" y="2469493"/>
+            <a:ext cx="11582403" cy="461665"/>
           </a:xfrm>
           <a:prstGeom prst="rect">
             <a:avLst/>
@@ -4960,7 +4967,8 @@
               <a:defRPr sz="1200"/>
             </a:pPr>
             <a:r>
-              <a:t>Identified edge cases through boundary analysis and state-transition modelling: concurrent booking submissions within the same millisecond, negative capacities, venue unavailability spanning across existing multi-day reservations, registration cancellations when waiting lists are empty vs populated, and rapid double-click form submissions.</a:t>
+              <a:rPr sz="1200"/>
+              <a:t>Identified edge cases through boundary analysis and state-transition modelling: concurrent booking submissions, negative capacities, venue unavailability across multi-day bookings, withdrawals that release a place to the waiting list (TC_E09S05_04), and double form submissions.</a:t>
             </a:r>
           </a:p>
         </p:txBody>
@@ -4979,7 +4987,7 @@
         </p:nvSpPr>
         <p:spPr>
           <a:xfrm>
-            <a:off x="258537" y="3374571"/>
+            <a:off x="258537" y="3007358"/>
             <a:ext cx="7535128" cy="369332"/>
           </a:xfrm>
           <a:prstGeom prst="rect">
@@ -5018,8 +5026,8 @@
         </p:nvSpPr>
         <p:spPr>
           <a:xfrm>
-            <a:off x="258537" y="3743903"/>
-            <a:ext cx="11582403" cy="1200329"/>
+            <a:off x="258537" y="3452890"/>
+            <a:ext cx="11582403" cy="461665"/>
           </a:xfrm>
           <a:prstGeom prst="rect">
             <a:avLst/>
@@ -5041,7 +5049,8 @@
               <a:defRPr sz="1200"/>
             </a:pPr>
             <a:r>
-              <a:t>Customer changes introduced asynchronous state dependencies (e.g. waiting-list notification and first-come claims, plus turnaround buffer overlaps) that required testing time-based workflows and multi-role interactions (Organiser, Venue Staff, Coordinator, Attendee). CFO guidance reinforced our focus on cost efficiency, preventing expensive database resets and keeping CI execution lean.</a:t>
+              <a:rPr sz="1200"/>
+              <a:t>Customer changes introduced asynchronous state dependencies (e.g. waiting-list notification and first-come claims, plus turnaround buffer overlaps) that required testing time-based workflows and multi-role interactions (Organiser, Venue Staff, Coordinator, Attendee).</a:t>
             </a:r>
           </a:p>
         </p:txBody>
@@ -5060,7 +5069,7 @@
         </p:nvSpPr>
         <p:spPr>
           <a:xfrm>
-            <a:off x="258536" y="4944232"/>
+            <a:off x="258536" y="3990755"/>
             <a:ext cx="10703631" cy="369332"/>
           </a:xfrm>
           <a:prstGeom prst="rect">
@@ -5099,8 +5108,8 @@
         </p:nvSpPr>
         <p:spPr>
           <a:xfrm>
-            <a:off x="258536" y="5387254"/>
-            <a:ext cx="11582403" cy="1200329"/>
+            <a:off x="258536" y="4436287"/>
+            <a:ext cx="11582403" cy="938719"/>
           </a:xfrm>
           <a:prstGeom prst="rect">
             <a:avLst/>
@@ -5122,16 +5131,19 @@
               <a:defRPr sz="1100"/>
             </a:pPr>
             <a:r>
+              <a:rPr sz="1100"/>
               <a:t>No - not all 379 test-case IDs. T-65/T-93 require a recorded manual run for each story accepted as Done: 739 run records and 509 evidence images in docs/testing/runs/. The 74 scaffold-only cases have had no human click-through.</a:t>
             </a:r>
           </a:p>
           <a:p>
             <a:r>
+              <a:rPr sz="1100"/>
               <a:t>• Process: Testers followed documented markdown scripts (docs/testing/manual/), set up preconditions via SQL scripts, executed flows in the browser, captured hand-taken screenshots, and committed session records to docs/testing/runs/.</a:t>
             </a:r>
           </a:p>
           <a:p>
             <a:r>
+              <a:rPr sz="1100"/>
               <a:t>• Challenges: Synchronising test accounts across roles without overwriting active test state required careful SQL fixture design.</a:t>
             </a:r>
           </a:p>
@@ -5413,7 +5425,7 @@
                         <a:defRPr sz="1000"/>
                       </a:pPr>
                       <a:r>
-                        <a:t>Pull request open/synchronize/reopen, push to main, and manual workflow dispatch.</a:t>
+                        <a:t>Pull requests to main (opened, synchronize, reopened, edited, ready for review), the merge queue, pushes to main and manual dispatch.</a:t>
                       </a:r>
                     </a:p>
                   </a:txBody>
@@ -5491,7 +5503,7 @@
                         <a:defRPr sz="1000"/>
                       </a:pPr>
                       <a:r>
-                        <a:t>Yes. Enforced via GitHub branch protection rules requiring all status checks to be green.</a:t>
+                        <a:t>Yes. Since 3 Oct 2026 a ruleset on main requires repository-checks, pr-conventions, lfs-guard and application-checks to pass, and merges go through a merge queue.</a:t>
                       </a:r>
                     </a:p>
                   </a:txBody>
@@ -5648,7 +5660,7 @@
                         <a:defRPr sz="1000"/>
                       </a:pPr>
                       <a:r>
-                        <a:t>Yes. An agent submitted a PR touching .agents/STATE.md directly. CI pr-conventions immediately blocked the merge, preventing severe branch conflict across teammate PRs.</a:t>
+                        <a:t>Yes. On PR #320 (event cancellation) the Typecheck step failed on commit cc7322f (run 39831097976): a test passed an option ByRoleOptions does not support, which a cached local tsc had missed. It was fixed before merge.</a:t>
                       </a:r>
                     </a:p>
                   </a:txBody>
@@ -5687,7 +5699,7 @@
                         <a:defRPr sz="1000"/>
                       </a:pPr>
                       <a:r>
-                        <a:t>Never bypassed CI. Branch protection rules strictly prohibited force pushes or administrative bypasses. All issues were resolved through proper fix commits.</a:t>
+                        <a:t>No force pushes or bypasses since the main ruleset (3 Oct 2026): it blocks non-fast-forward pushes and has no bypass actors. Before it existed, four PRs (#148, #165, #166, #167) were merged on 1 Oct without an approving review.</a:t>
                       </a:r>
                     </a:p>
                   </a:txBody>
@@ -5856,8 +5868,8 @@
         </p:nvSpPr>
         <p:spPr>
           <a:xfrm>
-            <a:off x="205646" y="2224898"/>
-            <a:ext cx="11582403" cy="1200329"/>
+            <a:off x="205646" y="2236562"/>
+            <a:ext cx="11582403" cy="1569660"/>
           </a:xfrm>
           <a:prstGeom prst="rect">
             <a:avLst/>
@@ -5879,22 +5891,26 @@
               <a:defRPr sz="1200"/>
             </a:pPr>
             <a:r>
+              <a:rPr sz="1200"/>
               <a:t>1. Derived-Document Drift Audits: CI runs python scripts/check.py and scripts/tc_coverage_audit.py, automatically validating that .env.template and tc-coverage.md never drift from actual codebase usage. Any discrepancy fails the build.</a:t>
             </a:r>
           </a:p>
           <a:p>
             <a:r>
-              <a:t>2. Continuity &amp; State Protection Gate: Custom pre-commit and CI hooks prevent feature branches from editing shared continuity logs (STATE.md, JOURNAL.md), eliminating merge conflicts across parallel developer agents.</a:t>
-            </a:r>
-          </a:p>
-          <a:p>
-            <a:r>
-              <a:t>3. Worktree &amp; Artifact Hygiene: Automated scanners warn developers of orphaned worktrees or unstaged test evidence, keeping local workspaces pristine and preventing accidental credential leakage.</a:t>
-            </a:r>
-          </a:p>
-          <a:p>
-            <a:r>
-              <a:t>Benefit: Absolute reproducibility, zero merge lockouts, and 100% auditable traceability.</a:t>
+              <a:rPr sz="1200"/>
+              <a:t>2. Continuity &amp; State Protection Gate: Custom pre-commit and CI hooks prevent feature branches from editing shared continuity logs (STATE.md, JOURNAL.md), so parallel PRs no longer conflict on them (decisions 0013 and 0014).</a:t>
+            </a:r>
+          </a:p>
+          <a:p>
+            <a:r>
+              <a:rPr sz="1200"/>
+              <a:t>3. Evidence and Credential Hygiene: a test-evidence check keeps each run record and its screenshots in the same commit, detect-secrets and TruffleHog scan for credentials, and scripts/check_worktrees.py reports stale worktrees.</a:t>
+            </a:r>
+          </a:p>
+          <a:p>
+            <a:r>
+              <a:rPr sz="1200"/>
+              <a:t>Benefit: derived files stay in step with the code, shared state files stopped causing PR conflicts, and every cited run has a durable record. The idea came from our own Sprint 2 conflicts on STATE.md and JOURNAL.md (decision 0013).</a:t>
             </a:r>
           </a:p>
         </p:txBody>
@@ -6749,6 +6765,11 @@
                   </a:txBody>
                   <a:tcPr anchor="ctr"/>
                 </a:tc>
+                <a:extLst>
+                  <a:ext uri="{0D108BD9-81ED-4DB2-BD59-A6C34878D82A}">
+                    <a16:rowId xmlns:a16="http://schemas.microsoft.com/office/drawing/2014/main" val="10001"/>
+                  </a:ext>
+                </a:extLst>
               </a:tr>
               <a:tr h="480000">
                 <a:tc>
@@ -6777,7 +6798,7 @@
                       </a:pPr>
                       <a:r>
                         <a:rPr lang="en-SG"/>
-                        <a:t>Venue management, booking workflows, near-match scoring, lost-venue recovery</a:t>
+                        <a:t>Venue management, booking workflows, near-match search results, lost-venue recovery</a:t>
                       </a:r>
                     </a:p>
                   </a:txBody>
@@ -6831,6 +6852,11 @@
                   </a:txBody>
                   <a:tcPr anchor="ctr"/>
                 </a:tc>
+                <a:extLst>
+                  <a:ext uri="{0D108BD9-81ED-4DB2-BD59-A6C34878D82A}">
+                    <a16:rowId xmlns:a16="http://schemas.microsoft.com/office/drawing/2014/main" val="10002"/>
+                  </a:ext>
+                </a:extLst>
               </a:tr>
               <a:tr h="480000">
                 <a:tc>
@@ -6913,6 +6939,11 @@
                   </a:txBody>
                   <a:tcPr anchor="ctr"/>
                 </a:tc>
+                <a:extLst>
+                  <a:ext uri="{0D108BD9-81ED-4DB2-BD59-A6C34878D82A}">
+                    <a16:rowId xmlns:a16="http://schemas.microsoft.com/office/drawing/2014/main" val="10003"/>
+                  </a:ext>
+                </a:extLst>
               </a:tr>
               <a:tr h="480000">
                 <a:tc>
@@ -6995,6 +7026,11 @@
                   </a:txBody>
                   <a:tcPr anchor="ctr"/>
                 </a:tc>
+                <a:extLst>
+                  <a:ext uri="{0D108BD9-81ED-4DB2-BD59-A6C34878D82A}">
+                    <a16:rowId xmlns:a16="http://schemas.microsoft.com/office/drawing/2014/main" val="10004"/>
+                  </a:ext>
+                </a:extLst>
               </a:tr>
               <a:tr h="480000">
                 <a:tc>
@@ -7077,6 +7113,11 @@
                   </a:txBody>
                   <a:tcPr anchor="ctr"/>
                 </a:tc>
+                <a:extLst>
+                  <a:ext uri="{0D108BD9-81ED-4DB2-BD59-A6C34878D82A}">
+                    <a16:rowId xmlns:a16="http://schemas.microsoft.com/office/drawing/2014/main" val="10005"/>
+                  </a:ext>
+                </a:extLst>
               </a:tr>
               <a:tr h="480000">
                 <a:tc>
@@ -7159,6 +7200,11 @@
                   </a:txBody>
                   <a:tcPr anchor="ctr"/>
                 </a:tc>
+                <a:extLst>
+                  <a:ext uri="{0D108BD9-81ED-4DB2-BD59-A6C34878D82A}">
+                    <a16:rowId xmlns:a16="http://schemas.microsoft.com/office/drawing/2014/main" val="10006"/>
+                  </a:ext>
+                </a:extLst>
               </a:tr>
             </a:tbl>
           </a:graphicData>
@@ -7317,7 +7363,7 @@
         </p:nvSpPr>
         <p:spPr>
           <a:xfrm>
-            <a:off x="205646" y="2224898"/>
+            <a:off x="205646" y="1959563"/>
             <a:ext cx="11582403" cy="1200329"/>
           </a:xfrm>
           <a:prstGeom prst="rect">
@@ -7332,7 +7378,7 @@
         </p:spPr>
         <p:txBody>
           <a:bodyPr wrap="square" rtlCol="0">
-            <a:spAutoFit/>
+            <a:noAutofit/>
           </a:bodyPr>
           <a:lstStyle/>
           <a:p>
@@ -7340,17 +7386,20 @@
               <a:defRPr sz="1200"/>
             </a:pPr>
             <a:r>
-              <a:t>• Public Interactive PostPlan Dashboard: Live Sprint 1–4 burndown, velocity and scope tracking is published at https://5p9t29p9jotq.postplan.dev (Draft ID: 5p9t29p9jotq), verified by check_postplan_html.py.</a:t>
-            </a:r>
-          </a:p>
-          <a:p>
-            <a:r>
+              <a:rPr sz="1200"/>
+              <a:t>• Public Interactive PostPlan Dashboard: Live Sprint 1–4 burndown, velocity and scope tracking is published at https://5p9t29p9jotq.postplan.dev (Draft ID: 5p9t29p9jotq).</a:t>
+            </a:r>
+          </a:p>
+          <a:p>
+            <a:r>
+              <a:rPr sz="1200"/>
               <a:t>• Definition of Done (T-65/T-93): Done stories are never reopened and every accepted story carries a recorded manual run (739 in docs/testing/runs/). Changed code is unit-tested to the 100% rule in review; open follow-ups are tracked, not hidden.</a:t>
             </a:r>
           </a:p>
           <a:p>
             <a:r>
-              <a:t>• Sustainable Velocity: Delivered 24 pts (S1), 40 pts (S2), 34 pts (S3), and 50 pts (S4 to date) of clean, robust product functionality without skipping review or compromising main branch stability.</a:t>
+              <a:rPr sz="1200"/>
+              <a:t>• Velocity: 24 pts (S1), 40 pts (S2) and 34 pts (S3) of accepted product stories, 32.7 pts per closed sprint, and 35 pts Done in S4 as of 29 Oct 2026 (PostPlan dashboard above).</a:t>
             </a:r>
           </a:p>
         </p:txBody>
@@ -8416,8 +8465,8 @@
         </p:nvSpPr>
         <p:spPr>
           <a:xfrm>
-            <a:off x="317045" y="1769954"/>
-            <a:ext cx="11582403" cy="646331"/>
+            <a:off x="317045" y="1846154"/>
+            <a:ext cx="11582403" cy="1092607"/>
           </a:xfrm>
           <a:prstGeom prst="rect">
             <a:avLst/>
@@ -8439,11 +8488,13 @@
               <a:defRPr sz="1300"/>
             </a:pPr>
             <a:r>
-              <a:t>Cancellation Policy Cascade &amp; Waitlist Priority:</a:t>
-            </a:r>
-          </a:p>
-          <a:p>
-            <a:r>
+              <a:rPr sz="1300"/>
+              <a:t>Cancellation Policy Cascade &amp; Waiting-List Claims:</a:t>
+            </a:r>
+          </a:p>
+          <a:p>
+            <a:r>
+              <a:rPr sz="1300"/>
               <a:t>Introducing post-confirmation cancellation rules and attendee waiting lists changed the transactional state machine. When a place is released, every waitlisted Attendee is notified and the place goes to whoever claims first (C-23, T-33, T-46): there is no ordered queue, no automatic promotion and no hold window. Cancelling an Event also notifies affected Attendees, closes obsolete change requests and releases Session arrangements in one transaction with audit records. This required atomic transactions, status polymorphism (#371) and regression tests.</a:t>
             </a:r>
           </a:p>
@@ -8463,7 +8514,7 @@
         </p:nvSpPr>
         <p:spPr>
           <a:xfrm>
-            <a:off x="247651" y="2416285"/>
+            <a:off x="247651" y="3014961"/>
             <a:ext cx="11745688" cy="369332"/>
           </a:xfrm>
           <a:prstGeom prst="rect">
@@ -8502,8 +8553,8 @@
         </p:nvSpPr>
         <p:spPr>
           <a:xfrm>
-            <a:off x="333734" y="2889296"/>
-            <a:ext cx="11582403" cy="3970318"/>
+            <a:off x="333734" y="3460493"/>
+            <a:ext cx="11582403" cy="1292662"/>
           </a:xfrm>
           <a:prstGeom prst="rect">
             <a:avLst/>
@@ -8525,16 +8576,19 @@
               <a:defRPr sz="1300"/>
             </a:pPr>
             <a:r>
+              <a:rPr sz="1300"/>
               <a:t>• Architecture &amp; Database: migration 0025 adds venue unavailability over existing bookings (#348); cancellation and release logic is in backend/src/modules/eventLifecycle/cancellation.ts and backend/src/modules/venueBooking/lostVenueRecovery.ts.</a:t>
             </a:r>
           </a:p>
           <a:p>
             <a:r>
+              <a:rPr sz="1300"/>
               <a:t>• Frontend: organiser event cancellation with a recorded reason, waiting-list and withdrawal states for Attendees, and booking replacement flows (frontend/src/features/events/, frontend/src/features/venue/).</a:t>
             </a:r>
           </a:p>
           <a:p>
             <a:r>
+              <a:rPr sz="1300"/>
               <a:t>• Testing &amp; Verification: automated suites eventCancellation.test.ts, cancellationRecovery.integration.test.ts and attendeeCapacity.test.ts, plus T-65 manual click-through records in docs/testing/runs/.</a:t>
             </a:r>
           </a:p>
@@ -8701,8 +8755,8 @@
         </p:nvSpPr>
         <p:spPr>
           <a:xfrm>
-            <a:off x="317045" y="1769954"/>
-            <a:ext cx="11582403" cy="646331"/>
+            <a:off x="317045" y="1846154"/>
+            <a:ext cx="11582403" cy="892552"/>
           </a:xfrm>
           <a:prstGeom prst="rect">
             <a:avLst/>
@@ -8724,12 +8778,14 @@
               <a:defRPr sz="1300"/>
             </a:pPr>
             <a:r>
+              <a:rPr sz="1300"/>
               <a:t>Venue Amenity Tagging &amp; Setup/Turnaround Buffer Visibility:</a:t>
             </a:r>
           </a:p>
           <a:p>
             <a:r>
-              <a:t>Displaying turnaround buffers and filtering venues by amenity tags had minimal structural impact. The underlying venue entity already tracked dimensions, layout capacities, and basic metadata. Buffers and tags operated as purely additive non-breaking attributes that did not disrupt existing booking state transitions or require state machine refactoring.</a:t>
+              <a:rPr sz="1300"/>
+              <a:t>Displaying turnaround buffers and filtering venues by amenity tags had minimal structural impact. The underlying venue entity already tracked capacity, supported layouts, facilities and accessibility features. Buffers and tags operated as purely additive non-breaking attributes that did not disrupt existing booking state transitions or require state machine refactoring.</a:t>
             </a:r>
           </a:p>
         </p:txBody>
@@ -8748,7 +8804,7 @@
         </p:nvSpPr>
         <p:spPr>
           <a:xfrm>
-            <a:off x="247651" y="2416285"/>
+            <a:off x="247651" y="2814906"/>
             <a:ext cx="11745688" cy="369332"/>
           </a:xfrm>
           <a:prstGeom prst="rect">
@@ -8787,8 +8843,8 @@
         </p:nvSpPr>
         <p:spPr>
           <a:xfrm>
-            <a:off x="304797" y="2792840"/>
-            <a:ext cx="11582403" cy="3970318"/>
+            <a:off x="304797" y="3260438"/>
+            <a:ext cx="11582403" cy="1292662"/>
           </a:xfrm>
           <a:prstGeom prst="rect">
             <a:avLst/>
@@ -8810,17 +8866,20 @@
               <a:defRPr sz="1300"/>
             </a:pPr>
             <a:r>
+              <a:rPr sz="1300"/>
               <a:t>• Backend: venue search and suitability gained optional amenity and accessibility filters and turnaround buffers (backend/src/modules/venueBooking/search.ts, suitability.ts).</a:t>
             </a:r>
           </a:p>
           <a:p>
             <a:r>
-              <a:t>• Frontend: amenity picker and buffer fields in VenueBookingForm.tsx, filters in VenueSearch.tsx (frontend/src/features/venue/).</a:t>
-            </a:r>
-          </a:p>
-          <a:p>
-            <a:r>
-              <a:t>• Verification: VenueBookingForm.test.tsx and VenueSearch.navigation.test.tsx, plus the venue search and suitability backend tests; booking state transitions unchanged.</a:t>
+              <a:rPr sz="1300"/>
+              <a:t>• Frontend: buffer fields in VenueForm.tsx, buffers shown in VenueCalendar.tsx, and facility and accessibility filters in VenueSearch.tsx (frontend/src/features/venue/).</a:t>
+            </a:r>
+          </a:p>
+          <a:p>
+            <a:r>
+              <a:rPr sz="1300"/>
+              <a:t>• Verification: VenueSearch.navigation.test.tsx, venueSearch.test.ts and venueSuitability.test.ts for the filters, and venueBufferConflicts.integration.test.ts for buffers; booking state transitions unchanged.</a:t>
             </a:r>
           </a:p>
         </p:txBody>
@@ -9231,7 +9290,7 @@
                         <a:defRPr sz="1000"/>
                       </a:pPr>
                       <a:r>
-                        <a:t>Wrote synthetic mocks hallucinating 100% pass rates by mocking away genuine DOM and network failures.</a:t>
+                        <a:t>Agent-driven browser runs produced screenshots that were offered as manual-run evidence (T-93).</a:t>
                       </a:r>
                     </a:p>
                   </a:txBody>
@@ -9246,7 +9305,7 @@
                         <a:defRPr sz="1000"/>
                       </a:pPr>
                       <a:r>
-                        <a:t>Enforced T-65 and T-93: mandatory execution of real E2E tests with hand-taken human screenshots stored in the repo.</a:t>
+                        <a:t>T-65 and T-93: every run used as evidence gets a record in the repo, and manual runs need hand-taken screenshots.</a:t>
                       </a:r>
                     </a:p>
                   </a:txBody>
@@ -9261,7 +9320,7 @@
                         <a:defRPr sz="1000"/>
                       </a:pPr>
                       <a:r>
-                        <a:t>Caught real browser rendering issues, focus management bugs, and layout overflows that mocks missed.</a:t>
+                        <a:t>Manual evidence shows what a person actually saw, and the click-throughs found real issues, e.g. the header clipping and unread-count follow-ups in #309.</a:t>
                       </a:r>
                     </a:p>
                   </a:txBody>
@@ -9276,7 +9335,7 @@
                         <a:defRPr sz="1000"/>
                       </a:pPr>
                       <a:r>
-                        <a:t>739 run records in docs/testing/runs/, evidence/ directories with PNGs (e.g. PR #368, PR #373)</a:t>
+                        <a:t>739 run records in docs/testing/runs/, evidence/ directories with PNGs (e.g. PR #366, PR #368)</a:t>
                       </a:r>
                     </a:p>
                   </a:txBody>
@@ -9313,7 +9372,7 @@
                         <a:defRPr sz="1000"/>
                       </a:pPr>
                       <a:r>
-                        <a:t>Generated simple CRUD routes that accepted concurrent requests, creating double-booking race conditions.</a:t>
+                        <a:t>Could generate simple CRUD routes that accept concurrent requests and allow double bookings.</a:t>
                       </a:r>
                     </a:p>
                   </a:txBody>
@@ -9343,7 +9402,7 @@
                         <a:defRPr sz="1000"/>
                       </a:pPr>
                       <a:r>
-                        <a:t>Guaranteed absolute transactional integrity, preventing double-bookings across concurrent organisers.</a:t>
+                        <a:t>Two overlapping claims on a venue cannot both be accepted, even when organisers submit at the same time.</a:t>
                       </a:r>
                     </a:p>
                   </a:txBody>
@@ -9527,7 +9586,101 @@
         </p:nvSpPr>
         <p:spPr>
           <a:xfrm>
-            <a:off x="304798" y="1839295"/>
+            <a:off x="304798" y="1915495"/>
+            <a:ext cx="11582403" cy="938719"/>
+          </a:xfrm>
+          <a:prstGeom prst="rect">
+            <a:avLst/>
+          </a:prstGeom>
+          <a:solidFill>
+            <a:schemeClr val="accent1">
+              <a:lumMod val="40000"/>
+              <a:lumOff val="60000"/>
+            </a:schemeClr>
+          </a:solidFill>
+        </p:spPr>
+        <p:txBody>
+          <a:bodyPr wrap="square" rtlCol="0">
+            <a:spAutoFit/>
+          </a:bodyPr>
+          <a:lstStyle/>
+          <a:p>
+            <a:pPr>
+              <a:defRPr sz="1100"/>
+            </a:pPr>
+            <a:r>
+              <a:rPr sz="1100"/>
+              <a:t>Yes. Two recorded examples:</a:t>
+            </a:r>
+          </a:p>
+          <a:p>
+            <a:r>
+              <a:rPr sz="1100"/>
+              <a:t>1. Agent-taken screenshots: some manual-run evidence came from agent-driven browser runs. T-93 (15 Oct 2026) ruled that only hand-taken screenshots count, so manual runs are now evidenced by hand (docs/bdr/B-team-decisions.md).</a:t>
+            </a:r>
+          </a:p>
+          <a:p>
+            <a:r>
+              <a:rPr sz="1100"/>
+              <a:t>2. Agent-prepared test data: in SCRUM-51's manual run, an agent's setup inserted an extra Session, which made the first request fail; it was removed before the successful run (docs/plans/scrum-51-equipment-catalogue.md).</a:t>
+            </a:r>
+          </a:p>
+        </p:txBody>
+      </p:sp>
+      <p:sp>
+        <p:nvSpPr>
+          <p:cNvPr id="6" name="TextBox 5">
+            <a:extLst>
+              <a:ext uri="{FF2B5EF4-FFF2-40B4-BE49-F238E27FC236}">
+                <a16:creationId xmlns:a16="http://schemas.microsoft.com/office/drawing/2014/main" id="{9BE95E68-C7E0-C4A8-BBB2-0B57BCA9F82E}"/>
+              </a:ext>
+            </a:extLst>
+          </p:cNvPr>
+          <p:cNvSpPr txBox="1"/>
+          <p:nvPr/>
+        </p:nvSpPr>
+        <p:spPr>
+          <a:xfrm>
+            <a:off x="258536" y="2930414"/>
+            <a:ext cx="11582403" cy="646331"/>
+          </a:xfrm>
+          <a:prstGeom prst="rect">
+            <a:avLst/>
+          </a:prstGeom>
+          <a:noFill/>
+        </p:spPr>
+        <p:txBody>
+          <a:bodyPr wrap="square">
+            <a:spAutoFit/>
+          </a:bodyPr>
+          <a:lstStyle/>
+          <a:p>
+            <a:pPr marL="285750" lvl="0" indent="-285750">
+              <a:buFont typeface="Arial" panose="020B0604020202020204" pitchFamily="34" charset="0"/>
+              <a:buChar char="•"/>
+            </a:pPr>
+            <a:r>
+              <a:rPr lang="en-SG"/>
+              <a:t>Which part of the final system contains the clearest evidence that your team contributed more than simply prompting an AI tool? Why?</a:t>
+            </a:r>
+          </a:p>
+        </p:txBody>
+      </p:sp>
+      <p:sp>
+        <p:nvSpPr>
+          <p:cNvPr id="7" name="TextBox 6">
+            <a:extLst>
+              <a:ext uri="{FF2B5EF4-FFF2-40B4-BE49-F238E27FC236}">
+                <a16:creationId xmlns:a16="http://schemas.microsoft.com/office/drawing/2014/main" id="{59C86061-B326-0CEF-944D-445CA85E4AED}"/>
+              </a:ext>
+            </a:extLst>
+          </p:cNvPr>
+          <p:cNvSpPr txBox="1"/>
+          <p:nvPr/>
+        </p:nvSpPr>
+        <p:spPr>
+          <a:xfrm>
+            <a:off x="258536" y="3652945"/>
             <a:ext cx="11582403" cy="923330"/>
           </a:xfrm>
           <a:prstGeom prst="rect">
@@ -9542,7 +9695,7 @@
         </p:spPr>
         <p:txBody>
           <a:bodyPr wrap="square" rtlCol="0">
-            <a:spAutoFit/>
+            <a:noAutofit/>
           </a:bodyPr>
           <a:lstStyle/>
           <a:p>
@@ -9550,32 +9703,18 @@
               <a:defRPr sz="1100"/>
             </a:pPr>
             <a:r>
-              <a:t>Yes. Three key incidents of AI-induced rework occurred:</a:t>
-            </a:r>
-          </a:p>
-          <a:p>
-            <a:r>
-              <a:t>1. Destructive Database Scripts: AI initially attempted to add db:reset calls to test fixtures, which would have wiped our team's shared Supabase database. The team halted execution and codified T-59 guardrails.</a:t>
-            </a:r>
-          </a:p>
-          <a:p>
-            <a:r>
-              <a:t>2. Flaky Async DOM Assertions: In RefusedEdit.navigation.test.tsx, AI generated synchronous expect(...).toHaveFocus() assertions that passed intermittently on fast machines but flaked in CI (#372). We refactored to web-first waitFor polling on the container element (#373).</a:t>
-            </a:r>
-          </a:p>
-          <a:p>
-            <a:r>
-              <a:t>3. Over-Mocking: AI mocked backend services so heavily in frontend tests that contract breakages slipped through unnoticed until manual click-through testing.</a:t>
-            </a:r>
-          </a:p>
-        </p:txBody>
-      </p:sp>
-      <p:sp>
-        <p:nvSpPr>
-          <p:cNvPr id="6" name="TextBox 5">
+              <a:rPr sz="1100"/>
+              <a:t>Venue booking concurrency and status polymorphism (PR #371) and E06-S06 rule B (T-100). The team designed the booking state machine and the first-accepted-claim rule, enforced with PostgreSQL row locks (FOR UPDATE) so two organisers claiming the same slot cannot both succeed. A plain generated status column does not handle that race.</a:t>
+            </a:r>
+          </a:p>
+        </p:txBody>
+      </p:sp>
+      <p:sp>
+        <p:nvSpPr>
+          <p:cNvPr id="9" name="TextBox 8">
             <a:extLst>
               <a:ext uri="{FF2B5EF4-FFF2-40B4-BE49-F238E27FC236}">
-                <a16:creationId xmlns:a16="http://schemas.microsoft.com/office/drawing/2014/main" id="{9BE95E68-C7E0-C4A8-BBB2-0B57BCA9F82E}"/>
+                <a16:creationId xmlns:a16="http://schemas.microsoft.com/office/drawing/2014/main" id="{69D81FF1-1C49-9CFC-94A6-52E09B3D2BE9}"/>
               </a:ext>
             </a:extLst>
           </p:cNvPr>
@@ -9584,8 +9723,8 @@
         </p:nvSpPr>
         <p:spPr>
           <a:xfrm>
-            <a:off x="258536" y="2795283"/>
-            <a:ext cx="11582403" cy="646331"/>
+            <a:off x="258536" y="4652475"/>
+            <a:ext cx="10779577" cy="369332"/>
           </a:xfrm>
           <a:prstGeom prst="rect">
             <a:avLst/>
@@ -9598,23 +9737,23 @@
           </a:bodyPr>
           <a:lstStyle/>
           <a:p>
-            <a:pPr marL="285750" lvl="0" indent="-285750">
+            <a:pPr marL="342900" lvl="0" indent="-342900">
               <a:buFont typeface="Arial" panose="020B0604020202020204" pitchFamily="34" charset="0"/>
               <a:buChar char="•"/>
             </a:pPr>
             <a:r>
               <a:rPr lang="en-SG"/>
-              <a:t>Which part of the final system contains the clearest evidence that your team contributed more than simply prompting an AI tool? Why?</a:t>
-            </a:r>
-          </a:p>
-        </p:txBody>
-      </p:sp>
-      <p:sp>
-        <p:nvSpPr>
-          <p:cNvPr id="7" name="TextBox 6">
+              <a:t>What decision required human judgement rather than simply code generation? Why?</a:t>
+            </a:r>
+          </a:p>
+        </p:txBody>
+      </p:sp>
+      <p:sp>
+        <p:nvSpPr>
+          <p:cNvPr id="11" name="TextBox 10">
             <a:extLst>
               <a:ext uri="{FF2B5EF4-FFF2-40B4-BE49-F238E27FC236}">
-                <a16:creationId xmlns:a16="http://schemas.microsoft.com/office/drawing/2014/main" id="{59C86061-B326-0CEF-944D-445CA85E4AED}"/>
+                <a16:creationId xmlns:a16="http://schemas.microsoft.com/office/drawing/2014/main" id="{9673A3EC-AB95-6574-5597-FB0C19177D73}"/>
               </a:ext>
             </a:extLst>
           </p:cNvPr>
@@ -9623,7 +9762,7 @@
         </p:nvSpPr>
         <p:spPr>
           <a:xfrm>
-            <a:off x="258536" y="3474272"/>
+            <a:off x="258536" y="5098007"/>
             <a:ext cx="11582403" cy="923330"/>
           </a:xfrm>
           <a:prstGeom prst="rect">
@@ -9638,7 +9777,7 @@
         </p:spPr>
         <p:txBody>
           <a:bodyPr wrap="square" rtlCol="0">
-            <a:spAutoFit/>
+            <a:noAutofit/>
           </a:bodyPr>
           <a:lstStyle/>
           <a:p>
@@ -9646,88 +9785,8 @@
               <a:defRPr sz="1100"/>
             </a:pPr>
             <a:r>
-              <a:t>The Venue Booking Concurrency &amp; Status Polymorphism Architecture (refactor/booking-status-polymorphism, PR #371, and E06-S06 Rule B). AI models consistently propose naive status strings without handling edge cases like concurrent approval race conditions, partial slot releases, or automatic withdrawal of conflicting holds. Our team architected the formal state machine, transaction isolation levels, and comprehensive rollback handling.</a:t>
-            </a:r>
-          </a:p>
-        </p:txBody>
-      </p:sp>
-      <p:sp>
-        <p:nvSpPr>
-          <p:cNvPr id="9" name="TextBox 8">
-            <a:extLst>
-              <a:ext uri="{FF2B5EF4-FFF2-40B4-BE49-F238E27FC236}">
-                <a16:creationId xmlns:a16="http://schemas.microsoft.com/office/drawing/2014/main" id="{69D81FF1-1C49-9CFC-94A6-52E09B3D2BE9}"/>
-              </a:ext>
-            </a:extLst>
-          </p:cNvPr>
-          <p:cNvSpPr txBox="1"/>
-          <p:nvPr/>
-        </p:nvSpPr>
-        <p:spPr>
-          <a:xfrm>
-            <a:off x="258536" y="4430260"/>
-            <a:ext cx="10779577" cy="369332"/>
-          </a:xfrm>
-          <a:prstGeom prst="rect">
-            <a:avLst/>
-          </a:prstGeom>
-          <a:noFill/>
-        </p:spPr>
-        <p:txBody>
-          <a:bodyPr wrap="square">
-            <a:spAutoFit/>
-          </a:bodyPr>
-          <a:lstStyle/>
-          <a:p>
-            <a:pPr marL="342900" lvl="0" indent="-342900">
-              <a:buFont typeface="Arial" panose="020B0604020202020204" pitchFamily="34" charset="0"/>
-              <a:buChar char="•"/>
-            </a:pPr>
-            <a:r>
-              <a:rPr lang="en-SG"/>
-              <a:t>What decision required human judgement rather than simply code generation? Why?</a:t>
-            </a:r>
-          </a:p>
-        </p:txBody>
-      </p:sp>
-      <p:sp>
-        <p:nvSpPr>
-          <p:cNvPr id="11" name="TextBox 10">
-            <a:extLst>
-              <a:ext uri="{FF2B5EF4-FFF2-40B4-BE49-F238E27FC236}">
-                <a16:creationId xmlns:a16="http://schemas.microsoft.com/office/drawing/2014/main" id="{9673A3EC-AB95-6574-5597-FB0C19177D73}"/>
-              </a:ext>
-            </a:extLst>
-          </p:cNvPr>
-          <p:cNvSpPr txBox="1"/>
-          <p:nvPr/>
-        </p:nvSpPr>
-        <p:spPr>
-          <a:xfrm>
-            <a:off x="258536" y="4799592"/>
-            <a:ext cx="11582403" cy="923330"/>
-          </a:xfrm>
-          <a:prstGeom prst="rect">
-            <a:avLst/>
-          </a:prstGeom>
-          <a:solidFill>
-            <a:schemeClr val="accent1">
-              <a:lumMod val="40000"/>
-              <a:lumOff val="60000"/>
-            </a:schemeClr>
-          </a:solidFill>
-        </p:spPr>
-        <p:txBody>
-          <a:bodyPr wrap="square" rtlCol="0">
-            <a:spAutoFit/>
-          </a:bodyPr>
-          <a:lstStyle/>
-          <a:p>
-            <a:pPr>
-              <a:defRPr sz="1100"/>
-            </a:pPr>
-            <a:r>
-              <a:t>Team Decision T-63 (Near-Match Venue Scoring) and Rule B Booking Claim Policy. When an organiser's requested capacity or equipment cannot be perfectly matched, human judgement was required to determine whether to reject outright or suggest suitable near-matches with clear warnings, balancing user experience against operational risk.</a:t>
+              <a:rPr sz="1100"/>
+              <a:t>Team decisions T-63 (E06-S01 near-match results) and T-100 (rule B). The customer gave no proximity thresholds (C-27, C-64), so instead of inventing filter-relaxation rules the team returns every matching venue with its mismatches flagged (capacity, layout, accessibility) and lets the organiser decide. T-100 is the Product Owner's 22 Oct 2026 reading of existing customer choices. Both needed judgement about what the customer meant.</a:t>
             </a:r>
           </a:p>
         </p:txBody>
@@ -9746,8 +9805,8 @@
         </p:nvSpPr>
         <p:spPr>
           <a:xfrm>
-            <a:off x="563336" y="5940246"/>
-            <a:ext cx="10746921" cy="369332"/>
+            <a:off x="563336" y="6097537"/>
+            <a:ext cx="10746921" cy="492443"/>
           </a:xfrm>
           <a:prstGeom prst="rect">
             <a:avLst/>
@@ -10100,7 +10159,7 @@
               <a:defRPr sz="1200"/>
             </a:pPr>
             <a:r>
-              <a:t>Constrained AI via repository guardrails: AGENTS.md instructions, pre-commit hooks (detect-secrets, check.py), max 2 open PR limit, four-section PR body templates, and strict forbidden actions (no db:reset, no modifying STATE.md).</a:t>
+              <a:t>Constrained AI via repository guardrails: AGENTS.md instructions, pre-commit hooks run by check.py (detect-secrets, protected continuity files, test-evidence checks), max 2 open PRs per author, a four-section PR body template, and forbidden actions (no db:reset against Supabase, no editing STATE.md or JOURNAL.md in a PR).</a:t>
             </a:r>
           </a:p>
         </p:txBody>
@@ -10142,7 +10201,7 @@
               <a:defRPr sz="1200"/>
             </a:pPr>
             <a:r>
-              <a:t>Verified every change through the 16-check CI matrix (application-checks, Playwright E2E, Vitest, repository checks), followed by human peer review and T-65 manual click-through execution.</a:t>
+              <a:t>Verified every change through the required CI checks (repository-checks, pr-conventions, lfs-guard, and application-checks with typecheck, Vitest, backend and Playwright tests), then human peer review and T-65/T-93 manual run records.</a:t>
             </a:r>
           </a:p>
         </p:txBody>
@@ -10184,7 +10243,7 @@
               <a:defRPr sz="1200"/>
             </a:pPr>
             <a:r>
-              <a:t>Owned complete responsibility for code quality, architectural decisions, Jira reconciliation, and final system stability. Rejected AI hallucinations immediately and took full accountability during Sprint Reviews.</a:t>
+              <a:t>Each story has a human owner, and the main ruleset requires the latest push to be approved by someone other than the pusher. Agent-written claims are checked against the repository in review, and the Definition of Done needs the Product Owner's recorded acceptance.</a:t>
             </a:r>
           </a:p>
         </p:txBody>
@@ -10348,8 +10407,8 @@
         </p:nvSpPr>
         <p:spPr>
           <a:xfrm>
-            <a:off x="258537" y="3228842"/>
-            <a:ext cx="11582403" cy="3416320"/>
+            <a:off x="258537" y="3577488"/>
+            <a:ext cx="11582403" cy="1692771"/>
           </a:xfrm>
           <a:prstGeom prst="rect">
             <a:avLst/>
@@ -10371,22 +10430,26 @@
               <a:defRPr sz="1300"/>
             </a:pPr>
             <a:r>
-              <a:t>• Trunk-Based Collaboration with Short-Lived Branches: Enforced strict branch prefixes (feature/, fix/, docs/, test/, chore/) tied directly to Jira keys (e.g. feature/SCRUM-216-e09-registration-list).</a:t>
-            </a:r>
-          </a:p>
-          <a:p>
-            <a:r>
+              <a:rPr sz="1300"/>
+              <a:t>• Trunk-Based Collaboration with Short-Lived Branches: branch names must start with feature/, fix/, chore/, docs/, test/, refactor/ or ci/ (scripts/check_metadata.py), preferably with the Jira key (e.g. feature/SCRUM-216-e09-registration-list).</a:t>
+            </a:r>
+          </a:p>
+          <a:p>
+            <a:r>
+              <a:rPr sz="1300"/>
               <a:t>• Guardrails &amp; PR Hygiene: Maximum 2 open PRs per author (scripts/check_pr_guardrails.py) prevented WIP bloat and merge debt. Every PR required four mandatory headers (What and why, Verification, Checklist, Follow-ups).</a:t>
             </a:r>
           </a:p>
           <a:p>
             <a:r>
-              <a:t>• Worktree Isolation: Utilised Git worktrees (sgConnectSphere2026-wt/) to review and test stacked branches without dirtying local environments, validated by check_worktrees.py.</a:t>
-            </a:r>
-          </a:p>
-          <a:p>
-            <a:r>
-              <a:t>• Linear Git History: Rebase-and-merge / squash workflow kept main clean, bisectable, and always production-ready, backed by branch protection rules.</a:t>
+              <a:rPr sz="1300"/>
+              <a:t>• Worktree Isolation: Git worktrees let us review and test other branches without disturbing our own checkout; scripts/check_worktrees.py reports them and cleans up disposable ones.</a:t>
+            </a:r>
+          </a:p>
+          <a:p>
+            <a:r>
+              <a:rPr sz="1300"/>
+              <a:t>• Linear History, Tightened Over Time: since 3 Oct 2026 a ruleset on main requires squash merges through a merge queue, linear history, four green checks and approval of the latest push, with no bypass actors. Before it, four PRs (#148, #165, #166, #167) merged on 1 Oct without an approving review.</a:t>
             </a:r>
           </a:p>
         </p:txBody>
@@ -10927,21 +10990,6 @@
 </file>
 
 <file path=customXml/item1.xml><?xml version="1.0" encoding="utf-8"?>
-<p:properties xmlns:p="http://schemas.microsoft.com/office/2006/metadata/properties" xmlns:xsi="http://www.w3.org/2001/XMLSchema-instance" xmlns:pc="http://schemas.microsoft.com/office/infopath/2007/PartnerControls">
-  <documentManagement>
-    <Comment xmlns="1b6a39ee-1380-4096-9882-8248104ba7f7" xsi:nil="true"/>
-    <TaxCatchAll xmlns="4604cec2-e769-4190-9d56-5d48f74b6442" xsi:nil="true"/>
-    <lcf76f155ced4ddcb4097134ff3c332f xmlns="1b6a39ee-1380-4096-9882-8248104ba7f7">
-      <Terms xmlns="http://schemas.microsoft.com/office/infopath/2007/PartnerControls"/>
-    </lcf76f155ced4ddcb4097134ff3c332f>
-    <_Flow_SignoffStatus xmlns="1b6a39ee-1380-4096-9882-8248104ba7f7" xsi:nil="true"/>
-    <_ip_UnifiedCompliancePolicyUIAction xmlns="http://schemas.microsoft.com/sharepoint/v3" xsi:nil="true"/>
-    <_ip_UnifiedCompliancePolicyProperties xmlns="http://schemas.microsoft.com/sharepoint/v3" xsi:nil="true"/>
-  </documentManagement>
-</p:properties>
-</file>
-
-<file path=customXml/item2.xml><?xml version="1.0" encoding="utf-8"?>
 <ct:contentTypeSchema xmlns:ct="http://schemas.microsoft.com/office/2006/metadata/contentType" xmlns:ma="http://schemas.microsoft.com/office/2006/metadata/properties/metaAttributes" ct:_="" ma:_="" ma:contentTypeName="Document" ma:contentTypeID="0x0101000C6AD1B51FFACD45B62528B91A79C429" ma:contentTypeVersion="23" ma:contentTypeDescription="Create a new document." ma:contentTypeScope="" ma:versionID="97ba3a6a0b227a1012b29520f700b4dc">
   <xsd:schema xmlns:xsd="http://www.w3.org/2001/XMLSchema" xmlns:xs="http://www.w3.org/2001/XMLSchema" xmlns:p="http://schemas.microsoft.com/office/2006/metadata/properties" xmlns:ns1="http://schemas.microsoft.com/sharepoint/v3" xmlns:ns2="1b6a39ee-1380-4096-9882-8248104ba7f7" xmlns:ns3="4604cec2-e769-4190-9d56-5d48f74b6442" targetNamespace="http://schemas.microsoft.com/office/2006/metadata/properties" ma:root="true" ma:fieldsID="22b11cefbfdf0abf8862b3c24cf41bb4" ns1:_="" ns2:_="" ns3:_="">
     <xsd:import namespace="http://schemas.microsoft.com/sharepoint/v3"/>
@@ -11233,6 +11281,21 @@
 </ct:contentTypeSchema>
 </file>
 
+<file path=customXml/item2.xml><?xml version="1.0" encoding="utf-8"?>
+<p:properties xmlns:p="http://schemas.microsoft.com/office/2006/metadata/properties" xmlns:xsi="http://www.w3.org/2001/XMLSchema-instance" xmlns:pc="http://schemas.microsoft.com/office/infopath/2007/PartnerControls">
+  <documentManagement>
+    <Comment xmlns="1b6a39ee-1380-4096-9882-8248104ba7f7" xsi:nil="true"/>
+    <TaxCatchAll xmlns="4604cec2-e769-4190-9d56-5d48f74b6442" xsi:nil="true"/>
+    <lcf76f155ced4ddcb4097134ff3c332f xmlns="1b6a39ee-1380-4096-9882-8248104ba7f7">
+      <Terms xmlns="http://schemas.microsoft.com/office/infopath/2007/PartnerControls"/>
+    </lcf76f155ced4ddcb4097134ff3c332f>
+    <_Flow_SignoffStatus xmlns="1b6a39ee-1380-4096-9882-8248104ba7f7" xsi:nil="true"/>
+    <_ip_UnifiedCompliancePolicyUIAction xmlns="http://schemas.microsoft.com/sharepoint/v3" xsi:nil="true"/>
+    <_ip_UnifiedCompliancePolicyProperties xmlns="http://schemas.microsoft.com/sharepoint/v3" xsi:nil="true"/>
+  </documentManagement>
+</p:properties>
+</file>
+
 <file path=customXml/item3.xml><?xml version="1.0" encoding="utf-8"?>
 <?mso-contentType ?>
 <FormTemplates xmlns="http://schemas.microsoft.com/sharepoint/v3/contenttype/forms">
@@ -11243,24 +11306,6 @@
 </file>
 
 <file path=customXml/itemProps1.xml><?xml version="1.0" encoding="utf-8"?>
-<ds:datastoreItem xmlns:ds="http://schemas.openxmlformats.org/officeDocument/2006/customXml" ds:itemID="{09BA482B-8E6A-4742-9540-4D6310874565}">
-  <ds:schemaRefs>
-    <ds:schemaRef ds:uri="http://schemas.microsoft.com/office/infopath/2007/PartnerControls"/>
-    <ds:schemaRef ds:uri="http://www.w3.org/XML/1998/namespace"/>
-    <ds:schemaRef ds:uri="http://schemas.microsoft.com/sharepoint/v3"/>
-    <ds:schemaRef ds:uri="http://schemas.openxmlformats.org/package/2006/metadata/core-properties"/>
-    <ds:schemaRef ds:uri="http://schemas.microsoft.com/office/2006/documentManagement/types"/>
-    <ds:schemaRef ds:uri="1b6a39ee-1380-4096-9882-8248104ba7f7"/>
-    <ds:schemaRef ds:uri="http://purl.org/dc/dcmitype/"/>
-    <ds:schemaRef ds:uri="http://purl.org/dc/terms/"/>
-    <ds:schemaRef ds:uri="4604cec2-e769-4190-9d56-5d48f74b6442"/>
-    <ds:schemaRef ds:uri="http://schemas.microsoft.com/office/2006/metadata/properties"/>
-    <ds:schemaRef ds:uri="http://purl.org/dc/elements/1.1/"/>
-  </ds:schemaRefs>
-</ds:datastoreItem>
-</file>
-
-<file path=customXml/itemProps2.xml><?xml version="1.0" encoding="utf-8"?>
 <ds:datastoreItem xmlns:ds="http://schemas.openxmlformats.org/officeDocument/2006/customXml" ds:itemID="{D059D256-26B8-4B06-8428-E58DD814FD47}">
   <ds:schemaRefs>
     <ds:schemaRef ds:uri="1b6a39ee-1380-4096-9882-8248104ba7f7"/>
@@ -11280,6 +11325,24 @@
 </ds:datastoreItem>
 </file>
 
+<file path=customXml/itemProps2.xml><?xml version="1.0" encoding="utf-8"?>
+<ds:datastoreItem xmlns:ds="http://schemas.openxmlformats.org/officeDocument/2006/customXml" ds:itemID="{09BA482B-8E6A-4742-9540-4D6310874565}">
+  <ds:schemaRefs>
+    <ds:schemaRef ds:uri="http://schemas.microsoft.com/office/infopath/2007/PartnerControls"/>
+    <ds:schemaRef ds:uri="http://www.w3.org/XML/1998/namespace"/>
+    <ds:schemaRef ds:uri="http://schemas.microsoft.com/sharepoint/v3"/>
+    <ds:schemaRef ds:uri="http://schemas.openxmlformats.org/package/2006/metadata/core-properties"/>
+    <ds:schemaRef ds:uri="http://schemas.microsoft.com/office/2006/documentManagement/types"/>
+    <ds:schemaRef ds:uri="1b6a39ee-1380-4096-9882-8248104ba7f7"/>
+    <ds:schemaRef ds:uri="http://purl.org/dc/dcmitype/"/>
+    <ds:schemaRef ds:uri="http://purl.org/dc/terms/"/>
+    <ds:schemaRef ds:uri="4604cec2-e769-4190-9d56-5d48f74b6442"/>
+    <ds:schemaRef ds:uri="http://schemas.microsoft.com/office/2006/metadata/properties"/>
+    <ds:schemaRef ds:uri="http://purl.org/dc/elements/1.1/"/>
+  </ds:schemaRefs>
+</ds:datastoreItem>
+</file>
+
 <file path=customXml/itemProps3.xml><?xml version="1.0" encoding="utf-8"?>
 <ds:datastoreItem xmlns:ds="http://schemas.openxmlformats.org/officeDocument/2006/customXml" ds:itemID="{8A3786A0-5047-42B7-BF02-BFA2F5340D8E}">
   <ds:schemaRefs>

</xml_diff>

<commit_message>
docs(slides): clarify Supabase reset evidence
Follow up to #374. Cite the recorded local Claude reset and qualify the shared database guard.
</commit_message>
<xml_diff>
--- a/docs/slides/presentation/Week 11 Presentation.pptx
+++ b/docs/slides/presentation/Week 11 Presentation.pptx
@@ -9208,7 +9208,7 @@
                         <a:defRPr sz="1000"/>
                       </a:pPr>
                       <a:r>
-                        <a:t>Could generate a db:reset that drops the schema of whatever DATABASE_URL points at, including the shared Supabase database.</a:t>
+                        <a:t>Claude reset and seeded local connectsphere_dev_stack (127.0.0.1) for the 28 Oct manual run.</a:t>
                       </a:r>
                     </a:p>
                   </a:txBody>
@@ -9223,7 +9223,7 @@
                         <a:defRPr sz="1000"/>
                       </a:pPr>
                       <a:r>
-                        <a:t>T-59: a separate test schema in the same Supabase project, transaction-rollback isolation for database tests, and isSafeResetTarget(), which refuses db:reset unless the host is local or the database name contains test or dev (or ALLOW_DATABASE_RESET is set on purpose).</a:t>
+                        <a:t>T-59 chose the shared-project test schema to avoid a second free-tier slot and DB URL. Only the deactivation integration test uses it with transaction rollback. Separately, the CLI refuses db:reset against Supabase's remote postgres target by default.</a:t>
                       </a:r>
                     </a:p>
                   </a:txBody>
@@ -9238,7 +9238,7 @@
                         <a:defRPr sz="1000"/>
                       </a:pPr>
                       <a:r>
-                        <a:t>Database tests and resets cannot wipe the shared Supabase data, and there is no second database URL to rotate.</a:t>
+                        <a:t>No shared Supabase reset is recorded. The default guard refuses it, but an explicit override can drop the public schema.</a:t>
                       </a:r>
                     </a:p>
                   </a:txBody>
@@ -9253,7 +9253,7 @@
                         <a:defRPr sz="1000"/>
                       </a:pPr>
                       <a:r>
-                        <a:t>docs/bdr/B-team-decisions.md (T-59), docs/testing/supabase-test-schema.md, backend/src/database/cli.ts (isSafeResetTarget)</a:t>
+                        <a:t>docs/testing/runs/20261028-205403-lexinphun2024-debug-frontend-e2e.md; docs/bdr/B-team-decisions.md (T-59); docs/testing/supabase-test-schema.md; backend/src/database/cli.ts</a:t>
                       </a:r>
                     </a:p>
                   </a:txBody>

</xml_diff>